<commit_message>
Add dark-theme technical report deck with current React architecture.
Co-authored-by: Cursor <cursoragent@cursor.com>
</commit_message>
<xml_diff>
--- a/docs/CampusAI-MCP-Deck-v5.pptx
+++ b/docs/CampusAI-MCP-Deck-v5.pptx
@@ -5,17 +5,17 @@
     <p:sldMasterId id="2147483648" r:id="rId1"/>
   </p:sldMasterIdLst>
   <p:sldIdLst>
-    <p:sldId id="256" r:id="rId7"/>
-    <p:sldId id="257" r:id="rId8"/>
-    <p:sldId id="258" r:id="rId9"/>
-    <p:sldId id="259" r:id="rId10"/>
-    <p:sldId id="260" r:id="rId11"/>
-    <p:sldId id="261" r:id="rId12"/>
-    <p:sldId id="262" r:id="rId13"/>
-    <p:sldId id="263" r:id="rId14"/>
-    <p:sldId id="264" r:id="rId15"/>
+    <p:sldId id="256" r:id="rId2"/>
+    <p:sldId id="257" r:id="rId3"/>
+    <p:sldId id="258" r:id="rId4"/>
+    <p:sldId id="259" r:id="rId5"/>
+    <p:sldId id="260" r:id="rId6"/>
+    <p:sldId id="261" r:id="rId7"/>
+    <p:sldId id="262" r:id="rId8"/>
+    <p:sldId id="263" r:id="rId9"/>
+    <p:sldId id="264" r:id="rId10"/>
   </p:sldIdLst>
-  <p:sldSz cx="12191695" cy="6858000" type="screen4x3"/>
+  <p:sldSz cx="12192000" cy="6858000"/>
   <p:notesSz cx="6858000" cy="9144000"/>
   <p:defaultTextStyle>
     <a:defPPr>
@@ -112,6 +112,22 @@
       </a:defRPr>
     </a:lvl9pPr>
   </p:defaultTextStyle>
+  <p:extLst>
+    <p:ext uri="{EFAFB233-063F-42B5-8137-9DF3F51BA10A}">
+      <p15:sldGuideLst xmlns:p15="http://schemas.microsoft.com/office/powerpoint/2012/main">
+        <p15:guide id="1" orient="horz" pos="2160">
+          <p15:clr>
+            <a:srgbClr val="A4A3A4"/>
+          </p15:clr>
+        </p15:guide>
+        <p15:guide id="2" pos="2880">
+          <p15:clr>
+            <a:srgbClr val="A4A3A4"/>
+          </p15:clr>
+        </p15:guide>
+      </p15:sldGuideLst>
+    </p:ext>
+  </p:extLst>
 </p:presentation>
 </file>
 
@@ -153,10 +169,9 @@
           <a:lstStyle/>
           <a:p>
             <a:r>
-              <a:rPr lang="en-US" smtClean="0"/>
+              <a:rPr lang="en-US"/>
               <a:t>Click to edit Master title style</a:t>
             </a:r>
-            <a:endParaRPr lang="en-US"/>
           </a:p>
         </p:txBody>
       </p:sp>
@@ -272,10 +287,9 @@
           </a:lstStyle>
           <a:p>
             <a:r>
-              <a:rPr lang="en-US" smtClean="0"/>
+              <a:rPr lang="en-US"/>
               <a:t>Click to edit Master subtitle style</a:t>
             </a:r>
-            <a:endParaRPr lang="en-US"/>
           </a:p>
         </p:txBody>
       </p:sp>
@@ -296,7 +310,7 @@
           <a:p>
             <a:fld id="{5BCAD085-E8A6-8845-BD4E-CB4CCA059FC4}" type="datetimeFigureOut">
               <a:rPr lang="en-US" smtClean="0"/>
-              <a:t>1/27/13</a:t>
+              <a:t>9/14/2026</a:t>
             </a:fld>
             <a:endParaRPr lang="en-US"/>
           </a:p>
@@ -390,10 +404,9 @@
           <a:lstStyle/>
           <a:p>
             <a:r>
-              <a:rPr lang="en-US" smtClean="0"/>
+              <a:rPr lang="en-US"/>
               <a:t>Click to edit Master title style</a:t>
             </a:r>
-            <a:endParaRPr lang="en-US"/>
           </a:p>
         </p:txBody>
       </p:sp>
@@ -414,38 +427,37 @@
           <a:p>
             <a:pPr lvl="0"/>
             <a:r>
-              <a:rPr lang="en-US" smtClean="0"/>
+              <a:rPr lang="en-US"/>
               <a:t>Click to edit Master text styles</a:t>
             </a:r>
           </a:p>
           <a:p>
             <a:pPr lvl="1"/>
             <a:r>
-              <a:rPr lang="en-US" smtClean="0"/>
+              <a:rPr lang="en-US"/>
               <a:t>Second level</a:t>
             </a:r>
           </a:p>
           <a:p>
             <a:pPr lvl="2"/>
             <a:r>
-              <a:rPr lang="en-US" smtClean="0"/>
+              <a:rPr lang="en-US"/>
               <a:t>Third level</a:t>
             </a:r>
           </a:p>
           <a:p>
             <a:pPr lvl="3"/>
             <a:r>
-              <a:rPr lang="en-US" smtClean="0"/>
+              <a:rPr lang="en-US"/>
               <a:t>Fourth level</a:t>
             </a:r>
           </a:p>
           <a:p>
             <a:pPr lvl="4"/>
             <a:r>
-              <a:rPr lang="en-US" smtClean="0"/>
+              <a:rPr lang="en-US"/>
               <a:t>Fifth level</a:t>
             </a:r>
-            <a:endParaRPr lang="en-US"/>
           </a:p>
         </p:txBody>
       </p:sp>
@@ -466,7 +478,7 @@
           <a:p>
             <a:fld id="{5BCAD085-E8A6-8845-BD4E-CB4CCA059FC4}" type="datetimeFigureOut">
               <a:rPr lang="en-US" smtClean="0"/>
-              <a:t>1/27/13</a:t>
+              <a:t>9/14/2026</a:t>
             </a:fld>
             <a:endParaRPr lang="en-US"/>
           </a:p>
@@ -565,10 +577,9 @@
           <a:lstStyle/>
           <a:p>
             <a:r>
-              <a:rPr lang="en-US" smtClean="0"/>
+              <a:rPr lang="en-US"/>
               <a:t>Click to edit Master title style</a:t>
             </a:r>
-            <a:endParaRPr lang="en-US"/>
           </a:p>
         </p:txBody>
       </p:sp>
@@ -594,38 +605,37 @@
           <a:p>
             <a:pPr lvl="0"/>
             <a:r>
-              <a:rPr lang="en-US" smtClean="0"/>
+              <a:rPr lang="en-US"/>
               <a:t>Click to edit Master text styles</a:t>
             </a:r>
           </a:p>
           <a:p>
             <a:pPr lvl="1"/>
             <a:r>
-              <a:rPr lang="en-US" smtClean="0"/>
+              <a:rPr lang="en-US"/>
               <a:t>Second level</a:t>
             </a:r>
           </a:p>
           <a:p>
             <a:pPr lvl="2"/>
             <a:r>
-              <a:rPr lang="en-US" smtClean="0"/>
+              <a:rPr lang="en-US"/>
               <a:t>Third level</a:t>
             </a:r>
           </a:p>
           <a:p>
             <a:pPr lvl="3"/>
             <a:r>
-              <a:rPr lang="en-US" smtClean="0"/>
+              <a:rPr lang="en-US"/>
               <a:t>Fourth level</a:t>
             </a:r>
           </a:p>
           <a:p>
             <a:pPr lvl="4"/>
             <a:r>
-              <a:rPr lang="en-US" smtClean="0"/>
+              <a:rPr lang="en-US"/>
               <a:t>Fifth level</a:t>
             </a:r>
-            <a:endParaRPr lang="en-US"/>
           </a:p>
         </p:txBody>
       </p:sp>
@@ -646,7 +656,7 @@
           <a:p>
             <a:fld id="{5BCAD085-E8A6-8845-BD4E-CB4CCA059FC4}" type="datetimeFigureOut">
               <a:rPr lang="en-US" smtClean="0"/>
-              <a:t>1/27/13</a:t>
+              <a:t>9/14/2026</a:t>
             </a:fld>
             <a:endParaRPr lang="en-US"/>
           </a:p>
@@ -740,10 +750,9 @@
           <a:lstStyle/>
           <a:p>
             <a:r>
-              <a:rPr lang="en-US" smtClean="0"/>
+              <a:rPr lang="en-US"/>
               <a:t>Click to edit Master title style</a:t>
             </a:r>
-            <a:endParaRPr lang="en-US"/>
           </a:p>
         </p:txBody>
       </p:sp>
@@ -764,38 +773,37 @@
           <a:p>
             <a:pPr lvl="0"/>
             <a:r>
-              <a:rPr lang="en-US" smtClean="0"/>
+              <a:rPr lang="en-US"/>
               <a:t>Click to edit Master text styles</a:t>
             </a:r>
           </a:p>
           <a:p>
             <a:pPr lvl="1"/>
             <a:r>
-              <a:rPr lang="en-US" smtClean="0"/>
+              <a:rPr lang="en-US"/>
               <a:t>Second level</a:t>
             </a:r>
           </a:p>
           <a:p>
             <a:pPr lvl="2"/>
             <a:r>
-              <a:rPr lang="en-US" smtClean="0"/>
+              <a:rPr lang="en-US"/>
               <a:t>Third level</a:t>
             </a:r>
           </a:p>
           <a:p>
             <a:pPr lvl="3"/>
             <a:r>
-              <a:rPr lang="en-US" smtClean="0"/>
+              <a:rPr lang="en-US"/>
               <a:t>Fourth level</a:t>
             </a:r>
           </a:p>
           <a:p>
             <a:pPr lvl="4"/>
             <a:r>
-              <a:rPr lang="en-US" smtClean="0"/>
+              <a:rPr lang="en-US"/>
               <a:t>Fifth level</a:t>
             </a:r>
-            <a:endParaRPr lang="en-US"/>
           </a:p>
         </p:txBody>
       </p:sp>
@@ -816,7 +824,7 @@
           <a:p>
             <a:fld id="{5BCAD085-E8A6-8845-BD4E-CB4CCA059FC4}" type="datetimeFigureOut">
               <a:rPr lang="en-US" smtClean="0"/>
-              <a:t>1/27/13</a:t>
+              <a:t>9/14/2026</a:t>
             </a:fld>
             <a:endParaRPr lang="en-US"/>
           </a:p>
@@ -919,10 +927,9 @@
           </a:lstStyle>
           <a:p>
             <a:r>
-              <a:rPr lang="en-US" smtClean="0"/>
+              <a:rPr lang="en-US"/>
               <a:t>Click to edit Master title style</a:t>
             </a:r>
-            <a:endParaRPr lang="en-US"/>
           </a:p>
         </p:txBody>
       </p:sp>
@@ -1039,7 +1046,7 @@
           <a:p>
             <a:pPr lvl="0"/>
             <a:r>
-              <a:rPr lang="en-US" smtClean="0"/>
+              <a:rPr lang="en-US"/>
               <a:t>Click to edit Master text styles</a:t>
             </a:r>
           </a:p>
@@ -1062,7 +1069,7 @@
           <a:p>
             <a:fld id="{5BCAD085-E8A6-8845-BD4E-CB4CCA059FC4}" type="datetimeFigureOut">
               <a:rPr lang="en-US" smtClean="0"/>
-              <a:t>1/27/13</a:t>
+              <a:t>9/14/2026</a:t>
             </a:fld>
             <a:endParaRPr lang="en-US"/>
           </a:p>
@@ -1156,10 +1163,9 @@
           <a:lstStyle/>
           <a:p>
             <a:r>
-              <a:rPr lang="en-US" smtClean="0"/>
+              <a:rPr lang="en-US"/>
               <a:t>Click to edit Master title style</a:t>
             </a:r>
-            <a:endParaRPr lang="en-US"/>
           </a:p>
         </p:txBody>
       </p:sp>
@@ -1213,38 +1219,37 @@
           <a:p>
             <a:pPr lvl="0"/>
             <a:r>
-              <a:rPr lang="en-US" smtClean="0"/>
+              <a:rPr lang="en-US"/>
               <a:t>Click to edit Master text styles</a:t>
             </a:r>
           </a:p>
           <a:p>
             <a:pPr lvl="1"/>
             <a:r>
-              <a:rPr lang="en-US" smtClean="0"/>
+              <a:rPr lang="en-US"/>
               <a:t>Second level</a:t>
             </a:r>
           </a:p>
           <a:p>
             <a:pPr lvl="2"/>
             <a:r>
-              <a:rPr lang="en-US" smtClean="0"/>
+              <a:rPr lang="en-US"/>
               <a:t>Third level</a:t>
             </a:r>
           </a:p>
           <a:p>
             <a:pPr lvl="3"/>
             <a:r>
-              <a:rPr lang="en-US" smtClean="0"/>
+              <a:rPr lang="en-US"/>
               <a:t>Fourth level</a:t>
             </a:r>
           </a:p>
           <a:p>
             <a:pPr lvl="4"/>
             <a:r>
-              <a:rPr lang="en-US" smtClean="0"/>
+              <a:rPr lang="en-US"/>
               <a:t>Fifth level</a:t>
             </a:r>
-            <a:endParaRPr lang="en-US"/>
           </a:p>
         </p:txBody>
       </p:sp>
@@ -1298,38 +1303,37 @@
           <a:p>
             <a:pPr lvl="0"/>
             <a:r>
-              <a:rPr lang="en-US" smtClean="0"/>
+              <a:rPr lang="en-US"/>
               <a:t>Click to edit Master text styles</a:t>
             </a:r>
           </a:p>
           <a:p>
             <a:pPr lvl="1"/>
             <a:r>
-              <a:rPr lang="en-US" smtClean="0"/>
+              <a:rPr lang="en-US"/>
               <a:t>Second level</a:t>
             </a:r>
           </a:p>
           <a:p>
             <a:pPr lvl="2"/>
             <a:r>
-              <a:rPr lang="en-US" smtClean="0"/>
+              <a:rPr lang="en-US"/>
               <a:t>Third level</a:t>
             </a:r>
           </a:p>
           <a:p>
             <a:pPr lvl="3"/>
             <a:r>
-              <a:rPr lang="en-US" smtClean="0"/>
+              <a:rPr lang="en-US"/>
               <a:t>Fourth level</a:t>
             </a:r>
           </a:p>
           <a:p>
             <a:pPr lvl="4"/>
             <a:r>
-              <a:rPr lang="en-US" smtClean="0"/>
+              <a:rPr lang="en-US"/>
               <a:t>Fifth level</a:t>
             </a:r>
-            <a:endParaRPr lang="en-US"/>
           </a:p>
         </p:txBody>
       </p:sp>
@@ -1350,7 +1354,7 @@
           <a:p>
             <a:fld id="{5BCAD085-E8A6-8845-BD4E-CB4CCA059FC4}" type="datetimeFigureOut">
               <a:rPr lang="en-US" smtClean="0"/>
-              <a:t>1/27/13</a:t>
+              <a:t>9/14/2026</a:t>
             </a:fld>
             <a:endParaRPr lang="en-US"/>
           </a:p>
@@ -1448,10 +1452,9 @@
           </a:lstStyle>
           <a:p>
             <a:r>
-              <a:rPr lang="en-US" smtClean="0"/>
+              <a:rPr lang="en-US"/>
               <a:t>Click to edit Master title style</a:t>
             </a:r>
-            <a:endParaRPr lang="en-US"/>
           </a:p>
         </p:txBody>
       </p:sp>
@@ -1514,7 +1517,7 @@
           <a:p>
             <a:pPr lvl="0"/>
             <a:r>
-              <a:rPr lang="en-US" smtClean="0"/>
+              <a:rPr lang="en-US"/>
               <a:t>Click to edit Master text styles</a:t>
             </a:r>
           </a:p>
@@ -1570,38 +1573,37 @@
           <a:p>
             <a:pPr lvl="0"/>
             <a:r>
-              <a:rPr lang="en-US" smtClean="0"/>
+              <a:rPr lang="en-US"/>
               <a:t>Click to edit Master text styles</a:t>
             </a:r>
           </a:p>
           <a:p>
             <a:pPr lvl="1"/>
             <a:r>
-              <a:rPr lang="en-US" smtClean="0"/>
+              <a:rPr lang="en-US"/>
               <a:t>Second level</a:t>
             </a:r>
           </a:p>
           <a:p>
             <a:pPr lvl="2"/>
             <a:r>
-              <a:rPr lang="en-US" smtClean="0"/>
+              <a:rPr lang="en-US"/>
               <a:t>Third level</a:t>
             </a:r>
           </a:p>
           <a:p>
             <a:pPr lvl="3"/>
             <a:r>
-              <a:rPr lang="en-US" smtClean="0"/>
+              <a:rPr lang="en-US"/>
               <a:t>Fourth level</a:t>
             </a:r>
           </a:p>
           <a:p>
             <a:pPr lvl="4"/>
             <a:r>
-              <a:rPr lang="en-US" smtClean="0"/>
+              <a:rPr lang="en-US"/>
               <a:t>Fifth level</a:t>
             </a:r>
-            <a:endParaRPr lang="en-US"/>
           </a:p>
         </p:txBody>
       </p:sp>
@@ -1664,7 +1666,7 @@
           <a:p>
             <a:pPr lvl="0"/>
             <a:r>
-              <a:rPr lang="en-US" smtClean="0"/>
+              <a:rPr lang="en-US"/>
               <a:t>Click to edit Master text styles</a:t>
             </a:r>
           </a:p>
@@ -1720,38 +1722,37 @@
           <a:p>
             <a:pPr lvl="0"/>
             <a:r>
-              <a:rPr lang="en-US" smtClean="0"/>
+              <a:rPr lang="en-US"/>
               <a:t>Click to edit Master text styles</a:t>
             </a:r>
           </a:p>
           <a:p>
             <a:pPr lvl="1"/>
             <a:r>
-              <a:rPr lang="en-US" smtClean="0"/>
+              <a:rPr lang="en-US"/>
               <a:t>Second level</a:t>
             </a:r>
           </a:p>
           <a:p>
             <a:pPr lvl="2"/>
             <a:r>
-              <a:rPr lang="en-US" smtClean="0"/>
+              <a:rPr lang="en-US"/>
               <a:t>Third level</a:t>
             </a:r>
           </a:p>
           <a:p>
             <a:pPr lvl="3"/>
             <a:r>
-              <a:rPr lang="en-US" smtClean="0"/>
+              <a:rPr lang="en-US"/>
               <a:t>Fourth level</a:t>
             </a:r>
           </a:p>
           <a:p>
             <a:pPr lvl="4"/>
             <a:r>
-              <a:rPr lang="en-US" smtClean="0"/>
+              <a:rPr lang="en-US"/>
               <a:t>Fifth level</a:t>
             </a:r>
-            <a:endParaRPr lang="en-US"/>
           </a:p>
         </p:txBody>
       </p:sp>
@@ -1772,7 +1773,7 @@
           <a:p>
             <a:fld id="{5BCAD085-E8A6-8845-BD4E-CB4CCA059FC4}" type="datetimeFigureOut">
               <a:rPr lang="en-US" smtClean="0"/>
-              <a:t>1/27/13</a:t>
+              <a:t>9/14/2026</a:t>
             </a:fld>
             <a:endParaRPr lang="en-US"/>
           </a:p>
@@ -1866,10 +1867,9 @@
           <a:lstStyle/>
           <a:p>
             <a:r>
-              <a:rPr lang="en-US" smtClean="0"/>
+              <a:rPr lang="en-US"/>
               <a:t>Click to edit Master title style</a:t>
             </a:r>
-            <a:endParaRPr lang="en-US"/>
           </a:p>
         </p:txBody>
       </p:sp>
@@ -1890,7 +1890,7 @@
           <a:p>
             <a:fld id="{5BCAD085-E8A6-8845-BD4E-CB4CCA059FC4}" type="datetimeFigureOut">
               <a:rPr lang="en-US" smtClean="0"/>
-              <a:t>1/27/13</a:t>
+              <a:t>9/14/2026</a:t>
             </a:fld>
             <a:endParaRPr lang="en-US"/>
           </a:p>
@@ -1985,7 +1985,7 @@
           <a:p>
             <a:fld id="{5BCAD085-E8A6-8845-BD4E-CB4CCA059FC4}" type="datetimeFigureOut">
               <a:rPr lang="en-US" smtClean="0"/>
-              <a:t>1/27/13</a:t>
+              <a:t>9/14/2026</a:t>
             </a:fld>
             <a:endParaRPr lang="en-US"/>
           </a:p>
@@ -2088,10 +2088,9 @@
           </a:lstStyle>
           <a:p>
             <a:r>
-              <a:rPr lang="en-US" smtClean="0"/>
+              <a:rPr lang="en-US"/>
               <a:t>Click to edit Master title style</a:t>
             </a:r>
-            <a:endParaRPr lang="en-US"/>
           </a:p>
         </p:txBody>
       </p:sp>
@@ -2145,38 +2144,37 @@
           <a:p>
             <a:pPr lvl="0"/>
             <a:r>
-              <a:rPr lang="en-US" smtClean="0"/>
+              <a:rPr lang="en-US"/>
               <a:t>Click to edit Master text styles</a:t>
             </a:r>
           </a:p>
           <a:p>
             <a:pPr lvl="1"/>
             <a:r>
-              <a:rPr lang="en-US" smtClean="0"/>
+              <a:rPr lang="en-US"/>
               <a:t>Second level</a:t>
             </a:r>
           </a:p>
           <a:p>
             <a:pPr lvl="2"/>
             <a:r>
-              <a:rPr lang="en-US" smtClean="0"/>
+              <a:rPr lang="en-US"/>
               <a:t>Third level</a:t>
             </a:r>
           </a:p>
           <a:p>
             <a:pPr lvl="3"/>
             <a:r>
-              <a:rPr lang="en-US" smtClean="0"/>
+              <a:rPr lang="en-US"/>
               <a:t>Fourth level</a:t>
             </a:r>
           </a:p>
           <a:p>
             <a:pPr lvl="4"/>
             <a:r>
-              <a:rPr lang="en-US" smtClean="0"/>
+              <a:rPr lang="en-US"/>
               <a:t>Fifth level</a:t>
             </a:r>
-            <a:endParaRPr lang="en-US"/>
           </a:p>
         </p:txBody>
       </p:sp>
@@ -2239,7 +2237,7 @@
           <a:p>
             <a:pPr lvl="0"/>
             <a:r>
-              <a:rPr lang="en-US" smtClean="0"/>
+              <a:rPr lang="en-US"/>
               <a:t>Click to edit Master text styles</a:t>
             </a:r>
           </a:p>
@@ -2262,7 +2260,7 @@
           <a:p>
             <a:fld id="{5BCAD085-E8A6-8845-BD4E-CB4CCA059FC4}" type="datetimeFigureOut">
               <a:rPr lang="en-US" smtClean="0"/>
-              <a:t>1/27/13</a:t>
+              <a:t>9/14/2026</a:t>
             </a:fld>
             <a:endParaRPr lang="en-US"/>
           </a:p>
@@ -2365,10 +2363,9 @@
           </a:lstStyle>
           <a:p>
             <a:r>
-              <a:rPr lang="en-US" smtClean="0"/>
+              <a:rPr lang="en-US"/>
               <a:t>Click to edit Master title style</a:t>
             </a:r>
-            <a:endParaRPr lang="en-US"/>
           </a:p>
         </p:txBody>
       </p:sp>
@@ -2492,7 +2489,7 @@
           <a:p>
             <a:pPr lvl="0"/>
             <a:r>
-              <a:rPr lang="en-US" smtClean="0"/>
+              <a:rPr lang="en-US"/>
               <a:t>Click to edit Master text styles</a:t>
             </a:r>
           </a:p>
@@ -2515,7 +2512,7 @@
           <a:p>
             <a:fld id="{5BCAD085-E8A6-8845-BD4E-CB4CCA059FC4}" type="datetimeFigureOut">
               <a:rPr lang="en-US" smtClean="0"/>
-              <a:t>1/27/13</a:t>
+              <a:t>9/14/2026</a:t>
             </a:fld>
             <a:endParaRPr lang="en-US"/>
           </a:p>
@@ -2624,10 +2621,9 @@
           <a:lstStyle/>
           <a:p>
             <a:r>
-              <a:rPr lang="en-US" smtClean="0"/>
+              <a:rPr lang="en-US"/>
               <a:t>Click to edit Master title style</a:t>
             </a:r>
-            <a:endParaRPr lang="en-US"/>
           </a:p>
         </p:txBody>
       </p:sp>
@@ -2658,38 +2654,37 @@
           <a:p>
             <a:pPr lvl="0"/>
             <a:r>
-              <a:rPr lang="en-US" smtClean="0"/>
+              <a:rPr lang="en-US"/>
               <a:t>Click to edit Master text styles</a:t>
             </a:r>
           </a:p>
           <a:p>
             <a:pPr lvl="1"/>
             <a:r>
-              <a:rPr lang="en-US" smtClean="0"/>
+              <a:rPr lang="en-US"/>
               <a:t>Second level</a:t>
             </a:r>
           </a:p>
           <a:p>
             <a:pPr lvl="2"/>
             <a:r>
-              <a:rPr lang="en-US" smtClean="0"/>
+              <a:rPr lang="en-US"/>
               <a:t>Third level</a:t>
             </a:r>
           </a:p>
           <a:p>
             <a:pPr lvl="3"/>
             <a:r>
-              <a:rPr lang="en-US" smtClean="0"/>
+              <a:rPr lang="en-US"/>
               <a:t>Fourth level</a:t>
             </a:r>
           </a:p>
           <a:p>
             <a:pPr lvl="4"/>
             <a:r>
-              <a:rPr lang="en-US" smtClean="0"/>
+              <a:rPr lang="en-US"/>
               <a:t>Fifth level</a:t>
             </a:r>
-            <a:endParaRPr lang="en-US"/>
           </a:p>
         </p:txBody>
       </p:sp>
@@ -2728,7 +2723,7 @@
           <a:p>
             <a:fld id="{5BCAD085-E8A6-8845-BD4E-CB4CCA059FC4}" type="datetimeFigureOut">
               <a:rPr lang="en-US" smtClean="0"/>
-              <a:t>1/27/13</a:t>
+              <a:t>9/14/2026</a:t>
             </a:fld>
             <a:endParaRPr lang="en-US"/>
           </a:p>
@@ -3087,7 +3082,7 @@
 </file>
 
 <file path=ppt/slides/slide1.xml><?xml version="1.0" encoding="utf-8"?>
-<p:sld xmlns:a="http://schemas.openxmlformats.org/drawingml/2006/main" xmlns:p="http://schemas.openxmlformats.org/presentationml/2006/main" xmlns:r="http://schemas.openxmlformats.org/officeDocument/2006/relationships">
+<p:sld xmlns:a="http://schemas.openxmlformats.org/drawingml/2006/main" xmlns:r="http://schemas.openxmlformats.org/officeDocument/2006/relationships" xmlns:p="http://schemas.openxmlformats.org/presentationml/2006/main">
   <p:cSld>
     <p:spTree>
       <p:nvGrpSpPr>
@@ -3095,7 +3090,14 @@
         <p:cNvGrpSpPr/>
         <p:nvPr/>
       </p:nvGrpSpPr>
-      <p:grpSpPr/>
+      <p:grpSpPr>
+        <a:xfrm>
+          <a:off x="0" y="0"/>
+          <a:ext cx="0" cy="0"/>
+          <a:chOff x="0" y="0"/>
+          <a:chExt cx="0" cy="0"/>
+        </a:xfrm>
+      </p:grpSpPr>
       <p:pic>
         <p:nvPicPr>
           <p:cNvPr id="2" name="Picture 1" descr="slide-bg-campus-plain.png"/>
@@ -3122,14 +3124,14 @@
       </p:pic>
       <p:sp>
         <p:nvSpPr>
-          <p:cNvPr id="3" name="TextBox 2"/>
+          <p:cNvPr id="4" name="TextBox 3"/>
           <p:cNvSpPr txBox="1"/>
           <p:nvPr/>
         </p:nvSpPr>
         <p:spPr>
           <a:xfrm>
-            <a:off x="640080" y="1783080"/>
-            <a:ext cx="10058400" cy="320040"/>
+            <a:off x="640080" y="2240280"/>
+            <a:ext cx="10515600" cy="822960"/>
           </a:xfrm>
           <a:prstGeom prst="rect">
             <a:avLst/>
@@ -3148,28 +3150,55 @@
               </a:spcAft>
             </a:pPr>
             <a:r>
-              <a:rPr sz="1500" b="1">
-                <a:solidFill>
-                  <a:srgbClr val="1F8A80"/>
-                </a:solidFill>
-                <a:latin typeface="Microsoft JhengHei"/>
-                <a:ea typeface="Microsoft JhengHei"/>
-              </a:rPr>
-              <a:t>Campus AI</a:t>
-            </a:r>
-          </a:p>
-        </p:txBody>
-      </p:sp>
-      <p:sp>
-        <p:nvSpPr>
-          <p:cNvPr id="4" name="TextBox 3"/>
+              <a:rPr sz="3400" b="1" dirty="0" err="1">
+                <a:solidFill>
+                  <a:srgbClr val="1C2428"/>
+                </a:solidFill>
+                <a:latin typeface="Microsoft JhengHei"/>
+                <a:ea typeface="Microsoft JhengHei"/>
+              </a:rPr>
+              <a:t>校園學生服務個人化</a:t>
+            </a:r>
+            <a:r>
+              <a:rPr sz="3400" b="1" dirty="0">
+                <a:solidFill>
+                  <a:srgbClr val="1C2428"/>
+                </a:solidFill>
+                <a:latin typeface="Microsoft JhengHei"/>
+                <a:ea typeface="Microsoft JhengHei"/>
+              </a:rPr>
+              <a:t> AI </a:t>
+            </a:r>
+            <a:r>
+              <a:rPr sz="3400" b="1" dirty="0" err="1">
+                <a:solidFill>
+                  <a:srgbClr val="1C2428"/>
+                </a:solidFill>
+                <a:latin typeface="Microsoft JhengHei"/>
+                <a:ea typeface="Microsoft JhengHei"/>
+              </a:rPr>
+              <a:t>助理</a:t>
+            </a:r>
+            <a:endParaRPr sz="3400" b="1" dirty="0">
+              <a:solidFill>
+                <a:srgbClr val="1C2428"/>
+              </a:solidFill>
+              <a:latin typeface="Microsoft JhengHei"/>
+              <a:ea typeface="Microsoft JhengHei"/>
+            </a:endParaRPr>
+          </a:p>
+        </p:txBody>
+      </p:sp>
+      <p:sp>
+        <p:nvSpPr>
+          <p:cNvPr id="5" name="TextBox 4"/>
           <p:cNvSpPr txBox="1"/>
           <p:nvPr/>
         </p:nvSpPr>
         <p:spPr>
           <a:xfrm>
-            <a:off x="640080" y="2240280"/>
-            <a:ext cx="10515600" cy="822960"/>
+            <a:off x="640080" y="3246120"/>
+            <a:ext cx="10515600" cy="914400"/>
           </a:xfrm>
           <a:prstGeom prst="rect">
             <a:avLst/>
@@ -3184,58 +3213,28 @@
           <a:p>
             <a:pPr algn="l">
               <a:spcAft>
-                <a:spcPts val="600"/>
-              </a:spcAft>
-            </a:pPr>
-            <a:r>
-              <a:rPr sz="3400" b="1">
-                <a:solidFill>
-                  <a:srgbClr val="1C2428"/>
-                </a:solidFill>
-                <a:latin typeface="Microsoft JhengHei"/>
-                <a:ea typeface="Microsoft JhengHei"/>
-              </a:rPr>
-              <a:t>校園學生服務個人化 AI 助理</a:t>
-            </a:r>
-          </a:p>
-        </p:txBody>
-      </p:sp>
-      <p:sp>
-        <p:nvSpPr>
-          <p:cNvPr id="5" name="TextBox 4"/>
-          <p:cNvSpPr txBox="1"/>
-          <p:nvPr/>
-        </p:nvSpPr>
-        <p:spPr>
-          <a:xfrm>
-            <a:off x="640080" y="3246120"/>
-            <a:ext cx="10515600" cy="914400"/>
-          </a:xfrm>
-          <a:prstGeom prst="rect">
-            <a:avLst/>
-          </a:prstGeom>
-          <a:noFill/>
-        </p:spPr>
-        <p:txBody>
-          <a:bodyPr wrap="square">
-            <a:spAutoFit/>
-          </a:bodyPr>
-          <a:lstStyle/>
-          <a:p>
-            <a:pPr algn="l">
-              <a:spcAft>
                 <a:spcPts val="800"/>
               </a:spcAft>
             </a:pPr>
             <a:r>
-              <a:rPr sz="1600" b="0">
+              <a:rPr sz="1600" b="0" dirty="0" err="1">
                 <a:solidFill>
                   <a:srgbClr val="5A656B"/>
                 </a:solidFill>
                 <a:latin typeface="Microsoft JhengHei"/>
                 <a:ea typeface="Microsoft JhengHei"/>
               </a:rPr>
-              <a:t>依身分切換入口，用對話處理獎學金、選課、活動與校務問題。</a:t>
+              <a:t>依身分切換入口，用對話處理獎學金、選課、活動與校務問題</a:t>
+            </a:r>
+            <a:r>
+              <a:rPr sz="1600" b="0" dirty="0">
+                <a:solidFill>
+                  <a:srgbClr val="5A656B"/>
+                </a:solidFill>
+                <a:latin typeface="Microsoft JhengHei"/>
+                <a:ea typeface="Microsoft JhengHei"/>
+              </a:rPr>
+              <a:t>。</a:t>
             </a:r>
           </a:p>
           <a:p>
@@ -3245,14 +3244,64 @@
               </a:spcAft>
             </a:pPr>
             <a:r>
-              <a:rPr sz="1600" b="0">
+              <a:rPr sz="1600" b="0" dirty="0" err="1">
                 <a:solidFill>
                   <a:srgbClr val="5A656B"/>
                 </a:solidFill>
                 <a:latin typeface="Microsoft JhengHei"/>
                 <a:ea typeface="Microsoft JhengHei"/>
               </a:rPr>
-              <a:t>正式資料查 SQL Server；校園問答檢索規章；Gemini 整理成回覆。</a:t>
+              <a:t>正式資料查</a:t>
+            </a:r>
+            <a:r>
+              <a:rPr sz="1600" b="0" dirty="0">
+                <a:solidFill>
+                  <a:srgbClr val="5A656B"/>
+                </a:solidFill>
+                <a:latin typeface="Microsoft JhengHei"/>
+                <a:ea typeface="Microsoft JhengHei"/>
+              </a:rPr>
+              <a:t> SQL </a:t>
+            </a:r>
+            <a:r>
+              <a:rPr sz="1600" b="0" dirty="0" err="1">
+                <a:solidFill>
+                  <a:srgbClr val="5A656B"/>
+                </a:solidFill>
+                <a:latin typeface="Microsoft JhengHei"/>
+                <a:ea typeface="Microsoft JhengHei"/>
+              </a:rPr>
+              <a:t>Server；校園問答檢索規章；Gemini</a:t>
+            </a:r>
+            <a:r>
+              <a:rPr sz="1600" b="0" dirty="0">
+                <a:solidFill>
+                  <a:srgbClr val="5A656B"/>
+                </a:solidFill>
+                <a:latin typeface="Microsoft JhengHei"/>
+                <a:ea typeface="Microsoft JhengHei"/>
+              </a:rPr>
+              <a:t> </a:t>
+            </a:r>
+            <a:r>
+              <a:rPr sz="1600" b="0" dirty="0" err="1">
+                <a:solidFill>
+                  <a:srgbClr val="5A656B"/>
+                </a:solidFill>
+                <a:latin typeface="Microsoft JhengHei"/>
+                <a:ea typeface="Microsoft JhengHei"/>
+              </a:rPr>
+              <a:t>整理成回覆</a:t>
+            </a:r>
+            <a:r>
+              <a:rPr sz="1600" b="0" dirty="0">
+                <a:solidFill>
+                  <a:srgbClr val="5A656B"/>
+                </a:solidFill>
+                <a:latin typeface="Microsoft JhengHei"/>
+                <a:ea typeface="Microsoft JhengHei"/>
+              </a:rPr>
+              <a:t>。</a:t>
             </a:r>
           </a:p>
         </p:txBody>
@@ -3299,6 +3348,7 @@
           <a:lstStyle/>
           <a:p>
             <a:pPr algn="ctr"/>
+            <a:endParaRPr/>
           </a:p>
         </p:txBody>
       </p:sp>
@@ -3384,6 +3434,7 @@
           <a:lstStyle/>
           <a:p>
             <a:pPr algn="ctr"/>
+            <a:endParaRPr/>
           </a:p>
         </p:txBody>
       </p:sp>
@@ -3469,6 +3520,7 @@
           <a:lstStyle/>
           <a:p>
             <a:pPr algn="ctr"/>
+            <a:endParaRPr/>
           </a:p>
         </p:txBody>
       </p:sp>
@@ -3554,6 +3606,7 @@
           <a:lstStyle/>
           <a:p>
             <a:pPr algn="ctr"/>
+            <a:endParaRPr/>
           </a:p>
         </p:txBody>
       </p:sp>
@@ -3639,6 +3692,7 @@
           <a:lstStyle/>
           <a:p>
             <a:pPr algn="ctr"/>
+            <a:endParaRPr/>
           </a:p>
         </p:txBody>
       </p:sp>
@@ -3724,6 +3778,7 @@
           <a:lstStyle/>
           <a:p>
             <a:pPr algn="ctr"/>
+            <a:endParaRPr/>
           </a:p>
         </p:txBody>
       </p:sp>
@@ -3795,15 +3850,42 @@
               </a:spcAft>
             </a:pPr>
             <a:r>
-              <a:rPr sz="1400" b="0">
-                <a:solidFill>
-                  <a:srgbClr val="1C2428"/>
-                </a:solidFill>
-                <a:latin typeface="Microsoft JhengHei"/>
-                <a:ea typeface="Microsoft JhengHei"/>
-              </a:rPr>
-              <a:t>簡報人：（請填姓名）</a:t>
-            </a:r>
+              <a:rPr sz="1400" b="0" dirty="0" err="1">
+                <a:solidFill>
+                  <a:srgbClr val="1C2428"/>
+                </a:solidFill>
+                <a:latin typeface="Microsoft JhengHei"/>
+                <a:ea typeface="Microsoft JhengHei"/>
+              </a:rPr>
+              <a:t>簡報人</a:t>
+            </a:r>
+            <a:r>
+              <a:rPr sz="1400" b="0" dirty="0">
+                <a:solidFill>
+                  <a:srgbClr val="1C2428"/>
+                </a:solidFill>
+                <a:latin typeface="Microsoft JhengHei"/>
+                <a:ea typeface="Microsoft JhengHei"/>
+              </a:rPr>
+              <a:t>：</a:t>
+            </a:r>
+            <a:r>
+              <a:rPr lang="zh-TW" altLang="en-US" sz="1400" b="0" dirty="0">
+                <a:solidFill>
+                  <a:srgbClr val="1C2428"/>
+                </a:solidFill>
+                <a:latin typeface="Microsoft JhengHei"/>
+                <a:ea typeface="Microsoft JhengHei"/>
+              </a:rPr>
+              <a:t>呂紹瑜</a:t>
+            </a:r>
+            <a:endParaRPr sz="1400" b="0" dirty="0">
+              <a:solidFill>
+                <a:srgbClr val="1C2428"/>
+              </a:solidFill>
+              <a:latin typeface="Microsoft JhengHei"/>
+              <a:ea typeface="Microsoft JhengHei"/>
+            </a:endParaRPr>
           </a:p>
         </p:txBody>
       </p:sp>
@@ -3816,7 +3898,7 @@
 </file>
 
 <file path=ppt/slides/slide2.xml><?xml version="1.0" encoding="utf-8"?>
-<p:sld xmlns:a="http://schemas.openxmlformats.org/drawingml/2006/main" xmlns:p="http://schemas.openxmlformats.org/presentationml/2006/main" xmlns:r="http://schemas.openxmlformats.org/officeDocument/2006/relationships">
+<p:sld xmlns:a="http://schemas.openxmlformats.org/drawingml/2006/main" xmlns:r="http://schemas.openxmlformats.org/officeDocument/2006/relationships" xmlns:p="http://schemas.openxmlformats.org/presentationml/2006/main">
   <p:cSld>
     <p:spTree>
       <p:nvGrpSpPr>
@@ -3824,7 +3906,14 @@
         <p:cNvGrpSpPr/>
         <p:nvPr/>
       </p:nvGrpSpPr>
-      <p:grpSpPr/>
+      <p:grpSpPr>
+        <a:xfrm>
+          <a:off x="0" y="0"/>
+          <a:ext cx="0" cy="0"/>
+          <a:chOff x="0" y="0"/>
+          <a:chExt cx="0" cy="0"/>
+        </a:xfrm>
+      </p:grpSpPr>
       <p:pic>
         <p:nvPicPr>
           <p:cNvPr id="2" name="Picture 1" descr="slide-bg-campus-plain.png"/>
@@ -3849,46 +3938,6 @@
           </a:prstGeom>
         </p:spPr>
       </p:pic>
-      <p:sp>
-        <p:nvSpPr>
-          <p:cNvPr id="3" name="TextBox 2"/>
-          <p:cNvSpPr txBox="1"/>
-          <p:nvPr/>
-        </p:nvSpPr>
-        <p:spPr>
-          <a:xfrm>
-            <a:off x="640080" y="320040"/>
-            <a:ext cx="9144000" cy="274320"/>
-          </a:xfrm>
-          <a:prstGeom prst="rect">
-            <a:avLst/>
-          </a:prstGeom>
-          <a:noFill/>
-        </p:spPr>
-        <p:txBody>
-          <a:bodyPr wrap="square">
-            <a:spAutoFit/>
-          </a:bodyPr>
-          <a:lstStyle/>
-          <a:p>
-            <a:pPr algn="l">
-              <a:spcAft>
-                <a:spcPts val="600"/>
-              </a:spcAft>
-            </a:pPr>
-            <a:r>
-              <a:rPr sz="1200" b="1">
-                <a:solidFill>
-                  <a:srgbClr val="1F8A80"/>
-                </a:solidFill>
-                <a:latin typeface="Microsoft JhengHei"/>
-                <a:ea typeface="Microsoft JhengHei"/>
-              </a:rPr>
-              <a:t>Campus AI</a:t>
-            </a:r>
-          </a:p>
-        </p:txBody>
-      </p:sp>
       <p:sp>
         <p:nvSpPr>
           <p:cNvPr id="4" name="TextBox 3"/>
@@ -4009,6 +4058,7 @@
           <a:lstStyle/>
           <a:p>
             <a:pPr algn="ctr"/>
+            <a:endParaRPr/>
           </a:p>
         </p:txBody>
       </p:sp>
@@ -4021,7 +4071,7 @@
         <p:spPr>
           <a:xfrm>
             <a:off x="640080" y="1554480"/>
-            <a:ext cx="10972800" cy="4846320"/>
+            <a:ext cx="10972800" cy="4544834"/>
           </a:xfrm>
           <a:prstGeom prst="rect">
             <a:avLst/>
@@ -4040,14 +4090,44 @@
               </a:spcAft>
             </a:pPr>
             <a:r>
-              <a:rPr sz="1800" b="0">
-                <a:solidFill>
-                  <a:srgbClr val="1C2428"/>
-                </a:solidFill>
-                <a:latin typeface="Microsoft JhengHei"/>
-                <a:ea typeface="Microsoft JhengHei"/>
-              </a:rPr>
-              <a:t>這是一個個人化 AI 助理。</a:t>
+              <a:rPr sz="1800" b="0" dirty="0" err="1">
+                <a:solidFill>
+                  <a:srgbClr val="1C2428"/>
+                </a:solidFill>
+                <a:latin typeface="Microsoft JhengHei"/>
+                <a:ea typeface="Microsoft JhengHei"/>
+              </a:rPr>
+              <a:t>這是一個個人化</a:t>
+            </a:r>
+            <a:r>
+              <a:rPr sz="1800" b="0" dirty="0">
+                <a:solidFill>
+                  <a:srgbClr val="1C2428"/>
+                </a:solidFill>
+                <a:latin typeface="Microsoft JhengHei"/>
+                <a:ea typeface="Microsoft JhengHei"/>
+              </a:rPr>
+              <a:t> AI </a:t>
+            </a:r>
+            <a:r>
+              <a:rPr sz="1800" b="0" dirty="0" err="1">
+                <a:solidFill>
+                  <a:srgbClr val="1C2428"/>
+                </a:solidFill>
+                <a:latin typeface="Microsoft JhengHei"/>
+                <a:ea typeface="Microsoft JhengHei"/>
+              </a:rPr>
+              <a:t>助理</a:t>
+            </a:r>
+            <a:r>
+              <a:rPr sz="1800" b="0" dirty="0">
+                <a:solidFill>
+                  <a:srgbClr val="1C2428"/>
+                </a:solidFill>
+                <a:latin typeface="Microsoft JhengHei"/>
+                <a:ea typeface="Microsoft JhengHei"/>
+              </a:rPr>
+              <a:t>。</a:t>
             </a:r>
           </a:p>
           <a:p>
@@ -4057,14 +4137,64 @@
               </a:spcAft>
             </a:pPr>
             <a:r>
-              <a:rPr sz="1800" b="0">
-                <a:solidFill>
-                  <a:srgbClr val="1C2428"/>
-                </a:solidFill>
-                <a:latin typeface="Microsoft JhengHei"/>
-                <a:ea typeface="Microsoft JhengHei"/>
-              </a:rPr>
-              <a:t>依登入身分，切到不同入口：</a:t>
+              <a:rPr sz="1800" b="0" dirty="0" err="1">
+                <a:solidFill>
+                  <a:srgbClr val="1C2428"/>
+                </a:solidFill>
+                <a:latin typeface="Microsoft JhengHei"/>
+                <a:ea typeface="Microsoft JhengHei"/>
+              </a:rPr>
+              <a:t>依登入身分</a:t>
+            </a:r>
+            <a:r>
+              <a:rPr lang="zh-TW" altLang="en-US" sz="1800" b="0" dirty="0">
+                <a:solidFill>
+                  <a:srgbClr val="1C2428"/>
+                </a:solidFill>
+                <a:latin typeface="Microsoft JhengHei"/>
+                <a:ea typeface="Microsoft JhengHei"/>
+              </a:rPr>
+              <a:t>不同</a:t>
+            </a:r>
+            <a:r>
+              <a:rPr sz="1800" b="0" dirty="0">
+                <a:solidFill>
+                  <a:srgbClr val="1C2428"/>
+                </a:solidFill>
+                <a:latin typeface="Microsoft JhengHei"/>
+                <a:ea typeface="Microsoft JhengHei"/>
+              </a:rPr>
+              <a:t>，切</a:t>
+            </a:r>
+            <a:r>
+              <a:rPr lang="zh-TW" altLang="en-US" sz="1800" b="0" dirty="0">
+                <a:solidFill>
+                  <a:srgbClr val="1C2428"/>
+                </a:solidFill>
+                <a:latin typeface="Microsoft JhengHei"/>
+                <a:ea typeface="Microsoft JhengHei"/>
+              </a:rPr>
+              <a:t>換</a:t>
+            </a:r>
+            <a:r>
+              <a:rPr sz="1800" b="0" dirty="0" err="1">
+                <a:solidFill>
+                  <a:srgbClr val="1C2428"/>
+                </a:solidFill>
+                <a:latin typeface="Microsoft JhengHei"/>
+                <a:ea typeface="Microsoft JhengHei"/>
+              </a:rPr>
+              <a:t>不同入口</a:t>
+            </a:r>
+            <a:r>
+              <a:rPr sz="1800" b="0" dirty="0">
+                <a:solidFill>
+                  <a:srgbClr val="1C2428"/>
+                </a:solidFill>
+                <a:latin typeface="Microsoft JhengHei"/>
+                <a:ea typeface="Microsoft JhengHei"/>
+              </a:rPr>
+              <a:t>：</a:t>
             </a:r>
           </a:p>
           <a:p>
@@ -4073,16 +4203,13 @@
                 <a:spcPts val="800"/>
               </a:spcAft>
             </a:pPr>
-            <a:r>
-              <a:rPr sz="1800" b="0">
-                <a:solidFill>
-                  <a:srgbClr val="1C2428"/>
-                </a:solidFill>
-                <a:latin typeface="Microsoft JhengHei"/>
-                <a:ea typeface="Microsoft JhengHei"/>
-              </a:rPr>
-              <a:t/>
-            </a:r>
+            <a:endParaRPr sz="1800" b="0" dirty="0">
+              <a:solidFill>
+                <a:srgbClr val="1C2428"/>
+              </a:solidFill>
+              <a:latin typeface="Microsoft JhengHei"/>
+              <a:ea typeface="Microsoft JhengHei"/>
+            </a:endParaRPr>
           </a:p>
           <a:p>
             <a:pPr algn="l">
@@ -4091,7 +4218,7 @@
               </a:spcAft>
             </a:pPr>
             <a:r>
-              <a:rPr sz="1800" b="0">
+              <a:rPr sz="1800" b="0" dirty="0" err="1">
                 <a:solidFill>
                   <a:srgbClr val="1C2428"/>
                 </a:solidFill>
@@ -4100,6 +4227,13 @@
               </a:rPr>
               <a:t>學生：獎學金、選課、活動</a:t>
             </a:r>
+            <a:endParaRPr sz="1800" b="0" dirty="0">
+              <a:solidFill>
+                <a:srgbClr val="1C2428"/>
+              </a:solidFill>
+              <a:latin typeface="Microsoft JhengHei"/>
+              <a:ea typeface="Microsoft JhengHei"/>
+            </a:endParaRPr>
           </a:p>
           <a:p>
             <a:pPr algn="l">
@@ -4108,7 +4242,7 @@
               </a:spcAft>
             </a:pPr>
             <a:r>
-              <a:rPr sz="1800" b="0">
+              <a:rPr sz="1800" b="0" dirty="0" err="1">
                 <a:solidFill>
                   <a:srgbClr val="1C2428"/>
                 </a:solidFill>
@@ -4117,6 +4251,13 @@
               </a:rPr>
               <a:t>教師：導生關懷、門檻提醒</a:t>
             </a:r>
+            <a:endParaRPr sz="1800" b="0" dirty="0">
+              <a:solidFill>
+                <a:srgbClr val="1C2428"/>
+              </a:solidFill>
+              <a:latin typeface="Microsoft JhengHei"/>
+              <a:ea typeface="Microsoft JhengHei"/>
+            </a:endParaRPr>
           </a:p>
           <a:p>
             <a:pPr algn="l">
@@ -4125,7 +4266,7 @@
               </a:spcAft>
             </a:pPr>
             <a:r>
-              <a:rPr sz="1800" b="0">
+              <a:rPr sz="1800" b="0" dirty="0" err="1">
                 <a:solidFill>
                   <a:srgbClr val="1C2428"/>
                 </a:solidFill>
@@ -4134,6 +4275,13 @@
               </a:rPr>
               <a:t>行政：校務研究、決策支援</a:t>
             </a:r>
+            <a:endParaRPr sz="1800" b="0" dirty="0">
+              <a:solidFill>
+                <a:srgbClr val="1C2428"/>
+              </a:solidFill>
+              <a:latin typeface="Microsoft JhengHei"/>
+              <a:ea typeface="Microsoft JhengHei"/>
+            </a:endParaRPr>
           </a:p>
           <a:p>
             <a:pPr algn="l">
@@ -4141,16 +4289,13 @@
                 <a:spcPts val="800"/>
               </a:spcAft>
             </a:pPr>
-            <a:r>
-              <a:rPr sz="1800" b="0">
-                <a:solidFill>
-                  <a:srgbClr val="1C2428"/>
-                </a:solidFill>
-                <a:latin typeface="Microsoft JhengHei"/>
-                <a:ea typeface="Microsoft JhengHei"/>
-              </a:rPr>
-              <a:t/>
-            </a:r>
+            <a:endParaRPr sz="1800" b="0" dirty="0">
+              <a:solidFill>
+                <a:srgbClr val="1C2428"/>
+              </a:solidFill>
+              <a:latin typeface="Microsoft JhengHei"/>
+              <a:ea typeface="Microsoft JhengHei"/>
+            </a:endParaRPr>
           </a:p>
           <a:p>
             <a:pPr algn="l">
@@ -4159,14 +4304,24 @@
               </a:spcAft>
             </a:pPr>
             <a:r>
-              <a:rPr sz="1800" b="0">
-                <a:solidFill>
-                  <a:srgbClr val="1C2428"/>
-                </a:solidFill>
-                <a:latin typeface="Microsoft JhengHei"/>
-                <a:ea typeface="Microsoft JhengHei"/>
-              </a:rPr>
-              <a:t>依不同身分切換不同入口。</a:t>
+              <a:rPr sz="1800" b="0" dirty="0" err="1">
+                <a:solidFill>
+                  <a:srgbClr val="1C2428"/>
+                </a:solidFill>
+                <a:latin typeface="Microsoft JhengHei"/>
+                <a:ea typeface="Microsoft JhengHei"/>
+              </a:rPr>
+              <a:t>依不同身分切換不同入口</a:t>
+            </a:r>
+            <a:r>
+              <a:rPr sz="1800" b="0" dirty="0">
+                <a:solidFill>
+                  <a:srgbClr val="1C2428"/>
+                </a:solidFill>
+                <a:latin typeface="Microsoft JhengHei"/>
+                <a:ea typeface="Microsoft JhengHei"/>
+              </a:rPr>
+              <a:t>。</a:t>
             </a:r>
           </a:p>
           <a:p>
@@ -4176,14 +4331,24 @@
               </a:spcAft>
             </a:pPr>
             <a:r>
-              <a:rPr sz="1800" b="0">
-                <a:solidFill>
-                  <a:srgbClr val="1C2428"/>
-                </a:solidFill>
-                <a:latin typeface="Microsoft JhengHei"/>
-                <a:ea typeface="Microsoft JhengHei"/>
-              </a:rPr>
-              <a:t>需求用對話提出，系統查完資料後回覆。</a:t>
+              <a:rPr sz="1800" b="0" dirty="0" err="1">
+                <a:solidFill>
+                  <a:srgbClr val="1C2428"/>
+                </a:solidFill>
+                <a:latin typeface="Microsoft JhengHei"/>
+                <a:ea typeface="Microsoft JhengHei"/>
+              </a:rPr>
+              <a:t>需求用對話提出，系統查完資料後回覆</a:t>
+            </a:r>
+            <a:r>
+              <a:rPr sz="1800" b="0" dirty="0">
+                <a:solidFill>
+                  <a:srgbClr val="1C2428"/>
+                </a:solidFill>
+                <a:latin typeface="Microsoft JhengHei"/>
+                <a:ea typeface="Microsoft JhengHei"/>
+              </a:rPr>
+              <a:t>。</a:t>
             </a:r>
           </a:p>
           <a:p>
@@ -4192,16 +4357,13 @@
                 <a:spcPts val="800"/>
               </a:spcAft>
             </a:pPr>
-            <a:r>
-              <a:rPr sz="1800" b="0">
-                <a:solidFill>
-                  <a:srgbClr val="1C2428"/>
-                </a:solidFill>
-                <a:latin typeface="Microsoft JhengHei"/>
-                <a:ea typeface="Microsoft JhengHei"/>
-              </a:rPr>
-              <a:t/>
-            </a:r>
+            <a:endParaRPr sz="1800" b="0" dirty="0">
+              <a:solidFill>
+                <a:srgbClr val="1C2428"/>
+              </a:solidFill>
+              <a:latin typeface="Microsoft JhengHei"/>
+              <a:ea typeface="Microsoft JhengHei"/>
+            </a:endParaRPr>
           </a:p>
           <a:p>
             <a:pPr algn="l">
@@ -4210,14 +4372,24 @@
               </a:spcAft>
             </a:pPr>
             <a:r>
-              <a:rPr sz="1800" b="0">
-                <a:solidFill>
-                  <a:srgbClr val="1C2428"/>
-                </a:solidFill>
-                <a:latin typeface="Microsoft JhengHei"/>
-                <a:ea typeface="Microsoft JhengHei"/>
-              </a:rPr>
-              <a:t>資格、成績等正式資料來自 SQL Server；</a:t>
+              <a:rPr sz="1800" b="0" dirty="0" err="1">
+                <a:solidFill>
+                  <a:srgbClr val="1C2428"/>
+                </a:solidFill>
+                <a:latin typeface="Microsoft JhengHei"/>
+                <a:ea typeface="Microsoft JhengHei"/>
+              </a:rPr>
+              <a:t>資格、成績等正式資料來自</a:t>
+            </a:r>
+            <a:r>
+              <a:rPr sz="1800" b="0" dirty="0">
+                <a:solidFill>
+                  <a:srgbClr val="1C2428"/>
+                </a:solidFill>
+                <a:latin typeface="Microsoft JhengHei"/>
+                <a:ea typeface="Microsoft JhengHei"/>
+              </a:rPr>
+              <a:t> SQL Server；</a:t>
             </a:r>
           </a:p>
           <a:p>
@@ -4227,14 +4399,24 @@
               </a:spcAft>
             </a:pPr>
             <a:r>
-              <a:rPr sz="1800" b="0">
-                <a:solidFill>
-                  <a:srgbClr val="1C2428"/>
-                </a:solidFill>
-                <a:latin typeface="Microsoft JhengHei"/>
-                <a:ea typeface="Microsoft JhengHei"/>
-              </a:rPr>
-              <a:t>一般校園問答則靠檢索規章文件。</a:t>
+              <a:rPr sz="1800" b="0" dirty="0" err="1">
+                <a:solidFill>
+                  <a:srgbClr val="1C2428"/>
+                </a:solidFill>
+                <a:latin typeface="Microsoft JhengHei"/>
+                <a:ea typeface="Microsoft JhengHei"/>
+              </a:rPr>
+              <a:t>一般校園問答則靠檢索規章文件</a:t>
+            </a:r>
+            <a:r>
+              <a:rPr sz="1800" b="0" dirty="0">
+                <a:solidFill>
+                  <a:srgbClr val="1C2428"/>
+                </a:solidFill>
+                <a:latin typeface="Microsoft JhengHei"/>
+                <a:ea typeface="Microsoft JhengHei"/>
+              </a:rPr>
+              <a:t>。</a:t>
             </a:r>
           </a:p>
         </p:txBody>
@@ -4248,7 +4430,7 @@
 </file>
 
 <file path=ppt/slides/slide3.xml><?xml version="1.0" encoding="utf-8"?>
-<p:sld xmlns:a="http://schemas.openxmlformats.org/drawingml/2006/main" xmlns:p="http://schemas.openxmlformats.org/presentationml/2006/main" xmlns:r="http://schemas.openxmlformats.org/officeDocument/2006/relationships">
+<p:sld xmlns:a="http://schemas.openxmlformats.org/drawingml/2006/main" xmlns:r="http://schemas.openxmlformats.org/officeDocument/2006/relationships" xmlns:p="http://schemas.openxmlformats.org/presentationml/2006/main">
   <p:cSld>
     <p:spTree>
       <p:nvGrpSpPr>
@@ -4256,7 +4438,14 @@
         <p:cNvGrpSpPr/>
         <p:nvPr/>
       </p:nvGrpSpPr>
-      <p:grpSpPr/>
+      <p:grpSpPr>
+        <a:xfrm>
+          <a:off x="0" y="0"/>
+          <a:ext cx="0" cy="0"/>
+          <a:chOff x="0" y="0"/>
+          <a:chExt cx="0" cy="0"/>
+        </a:xfrm>
+      </p:grpSpPr>
       <p:pic>
         <p:nvPicPr>
           <p:cNvPr id="2" name="Picture 1" descr="slide-bg-campus-plain.png"/>
@@ -4283,14 +4472,14 @@
       </p:pic>
       <p:sp>
         <p:nvSpPr>
-          <p:cNvPr id="3" name="TextBox 2"/>
+          <p:cNvPr id="4" name="TextBox 3"/>
           <p:cNvSpPr txBox="1"/>
           <p:nvPr/>
         </p:nvSpPr>
         <p:spPr>
           <a:xfrm>
-            <a:off x="640080" y="320040"/>
-            <a:ext cx="9144000" cy="256032"/>
+            <a:off x="640080" y="576072"/>
+            <a:ext cx="9601200" cy="411480"/>
           </a:xfrm>
           <a:prstGeom prst="rect">
             <a:avLst/>
@@ -4309,46 +4498,6 @@
               </a:spcAft>
             </a:pPr>
             <a:r>
-              <a:rPr sz="1200" b="1">
-                <a:solidFill>
-                  <a:srgbClr val="1F8A80"/>
-                </a:solidFill>
-                <a:latin typeface="Microsoft JhengHei"/>
-                <a:ea typeface="Microsoft JhengHei"/>
-              </a:rPr>
-              <a:t>Campus AI</a:t>
-            </a:r>
-          </a:p>
-        </p:txBody>
-      </p:sp>
-      <p:sp>
-        <p:nvSpPr>
-          <p:cNvPr id="4" name="TextBox 3"/>
-          <p:cNvSpPr txBox="1"/>
-          <p:nvPr/>
-        </p:nvSpPr>
-        <p:spPr>
-          <a:xfrm>
-            <a:off x="640080" y="576072"/>
-            <a:ext cx="9601200" cy="411480"/>
-          </a:xfrm>
-          <a:prstGeom prst="rect">
-            <a:avLst/>
-          </a:prstGeom>
-          <a:noFill/>
-        </p:spPr>
-        <p:txBody>
-          <a:bodyPr wrap="square">
-            <a:spAutoFit/>
-          </a:bodyPr>
-          <a:lstStyle/>
-          <a:p>
-            <a:pPr algn="l">
-              <a:spcAft>
-                <a:spcPts val="600"/>
-              </a:spcAft>
-            </a:pPr>
-            <a:r>
               <a:rPr sz="2600" b="1">
                 <a:solidFill>
                   <a:srgbClr val="1C2428"/>
@@ -4357,46 +4506,6 @@
                 <a:ea typeface="Microsoft JhengHei"/>
               </a:rPr>
               <a:t>系統怎麼分層？</a:t>
-            </a:r>
-          </a:p>
-        </p:txBody>
-      </p:sp>
-      <p:sp>
-        <p:nvSpPr>
-          <p:cNvPr id="5" name="TextBox 4"/>
-          <p:cNvSpPr txBox="1"/>
-          <p:nvPr/>
-        </p:nvSpPr>
-        <p:spPr>
-          <a:xfrm>
-            <a:off x="640080" y="1005840"/>
-            <a:ext cx="9601200" cy="274320"/>
-          </a:xfrm>
-          <a:prstGeom prst="rect">
-            <a:avLst/>
-          </a:prstGeom>
-          <a:noFill/>
-        </p:spPr>
-        <p:txBody>
-          <a:bodyPr wrap="square">
-            <a:spAutoFit/>
-          </a:bodyPr>
-          <a:lstStyle/>
-          <a:p>
-            <a:pPr algn="l">
-              <a:spcAft>
-                <a:spcPts val="600"/>
-              </a:spcAft>
-            </a:pPr>
-            <a:r>
-              <a:rPr sz="1300" b="0">
-                <a:solidFill>
-                  <a:srgbClr val="5A656B"/>
-                </a:solidFill>
-                <a:latin typeface="Microsoft JhengHei"/>
-                <a:ea typeface="Microsoft JhengHei"/>
-              </a:rPr>
-              <a:t>從畫面到資料</a:t>
             </a:r>
           </a:p>
         </p:txBody>
@@ -4483,6 +4592,7 @@
           <a:lstStyle/>
           <a:p>
             <a:pPr algn="ctr"/>
+            <a:endParaRPr/>
           </a:p>
         </p:txBody>
       </p:sp>
@@ -4535,7 +4645,7 @@
         <p:spPr>
           <a:xfrm>
             <a:off x="3017520" y="1554480"/>
-            <a:ext cx="8138160" cy="640080"/>
+            <a:ext cx="8138160" cy="323165"/>
           </a:xfrm>
           <a:prstGeom prst="rect">
             <a:avLst/>
@@ -4554,15 +4664,42 @@
               </a:spcAft>
             </a:pPr>
             <a:r>
-              <a:rPr sz="1500" b="0">
-                <a:solidFill>
-                  <a:srgbClr val="1C2428"/>
-                </a:solidFill>
-                <a:latin typeface="Microsoft JhengHei"/>
-                <a:ea typeface="Microsoft JhengHei"/>
-              </a:rPr>
-              <a:t>你看到的網站：主畫面、校務系統、平台服務、AI 功能</a:t>
-            </a:r>
+              <a:rPr sz="1500" b="0" dirty="0" err="1">
+                <a:solidFill>
+                  <a:srgbClr val="1C2428"/>
+                </a:solidFill>
+                <a:latin typeface="Microsoft JhengHei"/>
+                <a:ea typeface="Microsoft JhengHei"/>
+              </a:rPr>
+              <a:t>主畫面、校務系統、平台服務、AI</a:t>
+            </a:r>
+            <a:r>
+              <a:rPr sz="1500" b="0" dirty="0">
+                <a:solidFill>
+                  <a:srgbClr val="1C2428"/>
+                </a:solidFill>
+                <a:latin typeface="Microsoft JhengHei"/>
+                <a:ea typeface="Microsoft JhengHei"/>
+              </a:rPr>
+              <a:t> </a:t>
+            </a:r>
+            <a:r>
+              <a:rPr sz="1500" b="0" dirty="0" err="1">
+                <a:solidFill>
+                  <a:srgbClr val="1C2428"/>
+                </a:solidFill>
+                <a:latin typeface="Microsoft JhengHei"/>
+                <a:ea typeface="Microsoft JhengHei"/>
+              </a:rPr>
+              <a:t>功能</a:t>
+            </a:r>
+            <a:endParaRPr sz="1500" b="0" dirty="0">
+              <a:solidFill>
+                <a:srgbClr val="1C2428"/>
+              </a:solidFill>
+              <a:latin typeface="Microsoft JhengHei"/>
+              <a:ea typeface="Microsoft JhengHei"/>
+            </a:endParaRPr>
           </a:p>
         </p:txBody>
       </p:sp>
@@ -4608,6 +4745,7 @@
           <a:lstStyle/>
           <a:p>
             <a:pPr algn="ctr"/>
+            <a:endParaRPr/>
           </a:p>
         </p:txBody>
       </p:sp>
@@ -4660,7 +4798,7 @@
         <p:spPr>
           <a:xfrm>
             <a:off x="3017520" y="2724912"/>
-            <a:ext cx="8138160" cy="640080"/>
+            <a:ext cx="8138160" cy="323165"/>
           </a:xfrm>
           <a:prstGeom prst="rect">
             <a:avLst/>
@@ -4679,15 +4817,22 @@
               </a:spcAft>
             </a:pPr>
             <a:r>
-              <a:rPr sz="1500" b="0">
-                <a:solidFill>
-                  <a:srgbClr val="1C2428"/>
-                </a:solidFill>
-                <a:latin typeface="Microsoft JhengHei"/>
-                <a:ea typeface="Microsoft JhengHei"/>
-              </a:rPr>
-              <a:t>負責調度：推薦、規劃、申請、溝通、提醒、分析</a:t>
-            </a:r>
+              <a:rPr sz="1500" b="0" dirty="0" err="1">
+                <a:solidFill>
+                  <a:srgbClr val="1C2428"/>
+                </a:solidFill>
+                <a:latin typeface="Microsoft JhengHei"/>
+                <a:ea typeface="Microsoft JhengHei"/>
+              </a:rPr>
+              <a:t>推薦、規劃、申請、溝通、提醒、分析</a:t>
+            </a:r>
+            <a:endParaRPr sz="1500" b="0" dirty="0">
+              <a:solidFill>
+                <a:srgbClr val="1C2428"/>
+              </a:solidFill>
+              <a:latin typeface="Microsoft JhengHei"/>
+              <a:ea typeface="Microsoft JhengHei"/>
+            </a:endParaRPr>
           </a:p>
         </p:txBody>
       </p:sp>
@@ -4733,6 +4878,7 @@
           <a:lstStyle/>
           <a:p>
             <a:pPr algn="ctr"/>
+            <a:endParaRPr/>
           </a:p>
         </p:txBody>
       </p:sp>
@@ -4858,6 +5004,7 @@
           <a:lstStyle/>
           <a:p>
             <a:pPr algn="ctr"/>
+            <a:endParaRPr/>
           </a:p>
         </p:txBody>
       </p:sp>
@@ -4950,7 +5097,7 @@
 </file>
 
 <file path=ppt/slides/slide4.xml><?xml version="1.0" encoding="utf-8"?>
-<p:sld xmlns:a="http://schemas.openxmlformats.org/drawingml/2006/main" xmlns:p="http://schemas.openxmlformats.org/presentationml/2006/main" xmlns:r="http://schemas.openxmlformats.org/officeDocument/2006/relationships">
+<p:sld xmlns:a="http://schemas.openxmlformats.org/drawingml/2006/main" xmlns:r="http://schemas.openxmlformats.org/officeDocument/2006/relationships" xmlns:p="http://schemas.openxmlformats.org/presentationml/2006/main">
   <p:cSld>
     <p:spTree>
       <p:nvGrpSpPr>
@@ -4958,7 +5105,14 @@
         <p:cNvGrpSpPr/>
         <p:nvPr/>
       </p:nvGrpSpPr>
-      <p:grpSpPr/>
+      <p:grpSpPr>
+        <a:xfrm>
+          <a:off x="0" y="0"/>
+          <a:ext cx="0" cy="0"/>
+          <a:chOff x="0" y="0"/>
+          <a:chExt cx="0" cy="0"/>
+        </a:xfrm>
+      </p:grpSpPr>
       <p:pic>
         <p:nvPicPr>
           <p:cNvPr id="2" name="Picture 1" descr="slide-bg-campus-plain.png"/>
@@ -4985,14 +5139,14 @@
       </p:pic>
       <p:sp>
         <p:nvSpPr>
-          <p:cNvPr id="3" name="TextBox 2"/>
+          <p:cNvPr id="4" name="TextBox 3"/>
           <p:cNvSpPr txBox="1"/>
           <p:nvPr/>
         </p:nvSpPr>
         <p:spPr>
           <a:xfrm>
-            <a:off x="640080" y="320040"/>
-            <a:ext cx="9144000" cy="256032"/>
+            <a:off x="640080" y="576072"/>
+            <a:ext cx="9601200" cy="411480"/>
           </a:xfrm>
           <a:prstGeom prst="rect">
             <a:avLst/>
@@ -5011,54 +5165,24 @@
               </a:spcAft>
             </a:pPr>
             <a:r>
-              <a:rPr sz="1200" b="1">
-                <a:solidFill>
-                  <a:srgbClr val="1F8A80"/>
-                </a:solidFill>
-                <a:latin typeface="Microsoft JhengHei"/>
-                <a:ea typeface="Microsoft JhengHei"/>
-              </a:rPr>
-              <a:t>Campus AI</a:t>
-            </a:r>
-          </a:p>
-        </p:txBody>
-      </p:sp>
-      <p:sp>
-        <p:nvSpPr>
-          <p:cNvPr id="4" name="TextBox 3"/>
-          <p:cNvSpPr txBox="1"/>
-          <p:nvPr/>
-        </p:nvSpPr>
-        <p:spPr>
-          <a:xfrm>
-            <a:off x="640080" y="576072"/>
-            <a:ext cx="9601200" cy="411480"/>
-          </a:xfrm>
-          <a:prstGeom prst="rect">
-            <a:avLst/>
-          </a:prstGeom>
-          <a:noFill/>
-        </p:spPr>
-        <p:txBody>
-          <a:bodyPr wrap="square">
-            <a:spAutoFit/>
-          </a:bodyPr>
-          <a:lstStyle/>
-          <a:p>
-            <a:pPr algn="l">
-              <a:spcAft>
-                <a:spcPts val="600"/>
-              </a:spcAft>
-            </a:pPr>
-            <a:r>
-              <a:rPr sz="2600" b="1">
-                <a:solidFill>
-                  <a:srgbClr val="1C2428"/>
-                </a:solidFill>
-                <a:latin typeface="Microsoft JhengHei"/>
-                <a:ea typeface="Microsoft JhengHei"/>
-              </a:rPr>
-              <a:t>三種身分各自看什麼？</a:t>
+              <a:rPr sz="2600" b="1" dirty="0" err="1">
+                <a:solidFill>
+                  <a:srgbClr val="1C2428"/>
+                </a:solidFill>
+                <a:latin typeface="Microsoft JhengHei"/>
+                <a:ea typeface="Microsoft JhengHei"/>
+              </a:rPr>
+              <a:t>三種身分各自看什麼</a:t>
+            </a:r>
+            <a:r>
+              <a:rPr sz="2600" b="1" dirty="0">
+                <a:solidFill>
+                  <a:srgbClr val="1C2428"/>
+                </a:solidFill>
+                <a:latin typeface="Microsoft JhengHei"/>
+                <a:ea typeface="Microsoft JhengHei"/>
+              </a:rPr>
+              <a:t>？</a:t>
             </a:r>
           </a:p>
         </p:txBody>
@@ -5145,6 +5269,7 @@
           <a:lstStyle/>
           <a:p>
             <a:pPr algn="ctr"/>
+            <a:endParaRPr/>
           </a:p>
         </p:txBody>
       </p:sp>
@@ -5304,6 +5429,7 @@
           <a:lstStyle/>
           <a:p>
             <a:pPr algn="ctr"/>
+            <a:endParaRPr/>
           </a:p>
         </p:txBody>
       </p:sp>
@@ -5446,6 +5572,7 @@
           <a:lstStyle/>
           <a:p>
             <a:pPr algn="ctr"/>
+            <a:endParaRPr/>
           </a:p>
         </p:txBody>
       </p:sp>
@@ -5542,46 +5669,6 @@
                 <a:ea typeface="Microsoft JhengHei"/>
               </a:rPr>
               <a:t>決策支援</a:t>
-            </a:r>
-          </a:p>
-        </p:txBody>
-      </p:sp>
-      <p:sp>
-        <p:nvSpPr>
-          <p:cNvPr id="15" name="TextBox 14"/>
-          <p:cNvSpPr txBox="1"/>
-          <p:nvPr/>
-        </p:nvSpPr>
-        <p:spPr>
-          <a:xfrm>
-            <a:off x="640080" y="5394960"/>
-            <a:ext cx="10881360" cy="731520"/>
-          </a:xfrm>
-          <a:prstGeom prst="rect">
-            <a:avLst/>
-          </a:prstGeom>
-          <a:noFill/>
-        </p:spPr>
-        <p:txBody>
-          <a:bodyPr wrap="square">
-            <a:spAutoFit/>
-          </a:bodyPr>
-          <a:lstStyle/>
-          <a:p>
-            <a:pPr algn="l">
-              <a:spcAft>
-                <a:spcPts val="600"/>
-              </a:spcAft>
-            </a:pPr>
-            <a:r>
-              <a:rPr sz="1600" b="0">
-                <a:solidFill>
-                  <a:srgbClr val="5A656B"/>
-                </a:solidFill>
-                <a:latin typeface="Microsoft JhengHei"/>
-                <a:ea typeface="Microsoft JhengHei"/>
-              </a:rPr>
-              <a:t>同一個網站，登入後入口不同。</a:t>
             </a:r>
           </a:p>
         </p:txBody>
@@ -5595,7 +5682,7 @@
 </file>
 
 <file path=ppt/slides/slide5.xml><?xml version="1.0" encoding="utf-8"?>
-<p:sld xmlns:a="http://schemas.openxmlformats.org/drawingml/2006/main" xmlns:p="http://schemas.openxmlformats.org/presentationml/2006/main" xmlns:r="http://schemas.openxmlformats.org/officeDocument/2006/relationships">
+<p:sld xmlns:a="http://schemas.openxmlformats.org/drawingml/2006/main" xmlns:r="http://schemas.openxmlformats.org/officeDocument/2006/relationships" xmlns:p="http://schemas.openxmlformats.org/presentationml/2006/main">
   <p:cSld>
     <p:spTree>
       <p:nvGrpSpPr>
@@ -5603,7 +5690,14 @@
         <p:cNvGrpSpPr/>
         <p:nvPr/>
       </p:nvGrpSpPr>
-      <p:grpSpPr/>
+      <p:grpSpPr>
+        <a:xfrm>
+          <a:off x="0" y="0"/>
+          <a:ext cx="0" cy="0"/>
+          <a:chOff x="0" y="0"/>
+          <a:chExt cx="0" cy="0"/>
+        </a:xfrm>
+      </p:grpSpPr>
       <p:pic>
         <p:nvPicPr>
           <p:cNvPr id="2" name="Picture 1" descr="slide-bg-campus-plain.png"/>
@@ -5628,46 +5722,6 @@
           </a:prstGeom>
         </p:spPr>
       </p:pic>
-      <p:sp>
-        <p:nvSpPr>
-          <p:cNvPr id="3" name="TextBox 2"/>
-          <p:cNvSpPr txBox="1"/>
-          <p:nvPr/>
-        </p:nvSpPr>
-        <p:spPr>
-          <a:xfrm>
-            <a:off x="640080" y="320040"/>
-            <a:ext cx="9144000" cy="274320"/>
-          </a:xfrm>
-          <a:prstGeom prst="rect">
-            <a:avLst/>
-          </a:prstGeom>
-          <a:noFill/>
-        </p:spPr>
-        <p:txBody>
-          <a:bodyPr wrap="square">
-            <a:spAutoFit/>
-          </a:bodyPr>
-          <a:lstStyle/>
-          <a:p>
-            <a:pPr algn="l">
-              <a:spcAft>
-                <a:spcPts val="600"/>
-              </a:spcAft>
-            </a:pPr>
-            <a:r>
-              <a:rPr sz="1200" b="1">
-                <a:solidFill>
-                  <a:srgbClr val="1F8A80"/>
-                </a:solidFill>
-                <a:latin typeface="Microsoft JhengHei"/>
-                <a:ea typeface="Microsoft JhengHei"/>
-              </a:rPr>
-              <a:t>Campus AI</a:t>
-            </a:r>
-          </a:p>
-        </p:txBody>
-      </p:sp>
       <p:sp>
         <p:nvSpPr>
           <p:cNvPr id="4" name="TextBox 3"/>
@@ -5788,6 +5842,7 @@
           <a:lstStyle/>
           <a:p>
             <a:pPr algn="ctr"/>
+            <a:endParaRPr/>
           </a:p>
         </p:txBody>
       </p:sp>
@@ -5835,6 +5890,20 @@
                 <a:spcPts val="700"/>
               </a:spcAft>
             </a:pPr>
+            <a:endParaRPr sz="1700" b="0">
+              <a:solidFill>
+                <a:srgbClr val="1C2428"/>
+              </a:solidFill>
+              <a:latin typeface="Microsoft JhengHei"/>
+              <a:ea typeface="Microsoft JhengHei"/>
+            </a:endParaRPr>
+          </a:p>
+          <a:p>
+            <a:pPr algn="l">
+              <a:spcAft>
+                <a:spcPts val="700"/>
+              </a:spcAft>
+            </a:pPr>
             <a:r>
               <a:rPr sz="1700" b="0">
                 <a:solidFill>
@@ -5843,7 +5912,7 @@
                 <a:latin typeface="Microsoft JhengHei"/>
                 <a:ea typeface="Microsoft JhengHei"/>
               </a:rPr>
-              <a:t/>
+              <a:t>校務系統：學生資料、課程、活動、申請、行事曆。</a:t>
             </a:r>
           </a:p>
           <a:p>
@@ -5860,7 +5929,7 @@
                 <a:latin typeface="Microsoft JhengHei"/>
                 <a:ea typeface="Microsoft JhengHei"/>
               </a:rPr>
-              <a:t>校務系統：學生資料、課程、活動、申請、行事曆。</a:t>
+              <a:t>之後若要接真實校務，入口已經留好。</a:t>
             </a:r>
           </a:p>
           <a:p>
@@ -5869,6 +5938,20 @@
                 <a:spcPts val="700"/>
               </a:spcAft>
             </a:pPr>
+            <a:endParaRPr sz="1700" b="0">
+              <a:solidFill>
+                <a:srgbClr val="1C2428"/>
+              </a:solidFill>
+              <a:latin typeface="Microsoft JhengHei"/>
+              <a:ea typeface="Microsoft JhengHei"/>
+            </a:endParaRPr>
+          </a:p>
+          <a:p>
+            <a:pPr algn="l">
+              <a:spcAft>
+                <a:spcPts val="700"/>
+              </a:spcAft>
+            </a:pPr>
             <a:r>
               <a:rPr sz="1700" b="0">
                 <a:solidFill>
@@ -5877,7 +5960,7 @@
                 <a:latin typeface="Microsoft JhengHei"/>
                 <a:ea typeface="Microsoft JhengHei"/>
               </a:rPr>
-              <a:t>之後若要接真實校務，入口已經留好。</a:t>
+              <a:t>平台服務：身分驗證、權限、Tool Calling。</a:t>
             </a:r>
           </a:p>
           <a:p>
@@ -5894,7 +5977,7 @@
                 <a:latin typeface="Microsoft JhengHei"/>
                 <a:ea typeface="Microsoft JhengHei"/>
               </a:rPr>
-              <a:t/>
+              <a:t>處理的是「誰能用、能用到哪」。</a:t>
             </a:r>
           </a:p>
           <a:p>
@@ -5903,6 +5986,20 @@
                 <a:spcPts val="700"/>
               </a:spcAft>
             </a:pPr>
+            <a:endParaRPr sz="1700" b="0">
+              <a:solidFill>
+                <a:srgbClr val="1C2428"/>
+              </a:solidFill>
+              <a:latin typeface="Microsoft JhengHei"/>
+              <a:ea typeface="Microsoft JhengHei"/>
+            </a:endParaRPr>
+          </a:p>
+          <a:p>
+            <a:pPr algn="l">
+              <a:spcAft>
+                <a:spcPts val="700"/>
+              </a:spcAft>
+            </a:pPr>
             <a:r>
               <a:rPr sz="1700" b="0">
                 <a:solidFill>
@@ -5911,7 +6008,7 @@
                 <a:latin typeface="Microsoft JhengHei"/>
                 <a:ea typeface="Microsoft JhengHei"/>
               </a:rPr>
-              <a:t>平台服務：身分驗證、權限、Tool Calling。</a:t>
+              <a:t>AI 功能：真正能對話的助理。</a:t>
             </a:r>
           </a:p>
           <a:p>
@@ -5928,7 +6025,7 @@
                 <a:latin typeface="Microsoft JhengHei"/>
                 <a:ea typeface="Microsoft JhengHei"/>
               </a:rPr>
-              <a:t>處理的是「誰能用、能用到哪」。</a:t>
+              <a:t>問答、獎學金、選課、活動都從這裡進。</a:t>
             </a:r>
           </a:p>
           <a:p>
@@ -5937,67 +6034,13 @@
                 <a:spcPts val="700"/>
               </a:spcAft>
             </a:pPr>
-            <a:r>
-              <a:rPr sz="1700" b="0">
-                <a:solidFill>
-                  <a:srgbClr val="1C2428"/>
-                </a:solidFill>
-                <a:latin typeface="Microsoft JhengHei"/>
-                <a:ea typeface="Microsoft JhengHei"/>
-              </a:rPr>
-              <a:t/>
-            </a:r>
-          </a:p>
-          <a:p>
-            <a:pPr algn="l">
-              <a:spcAft>
-                <a:spcPts val="700"/>
-              </a:spcAft>
-            </a:pPr>
-            <a:r>
-              <a:rPr sz="1700" b="0">
-                <a:solidFill>
-                  <a:srgbClr val="1C2428"/>
-                </a:solidFill>
-                <a:latin typeface="Microsoft JhengHei"/>
-                <a:ea typeface="Microsoft JhengHei"/>
-              </a:rPr>
-              <a:t>AI 功能：真正能對話的助理。</a:t>
-            </a:r>
-          </a:p>
-          <a:p>
-            <a:pPr algn="l">
-              <a:spcAft>
-                <a:spcPts val="700"/>
-              </a:spcAft>
-            </a:pPr>
-            <a:r>
-              <a:rPr sz="1700" b="0">
-                <a:solidFill>
-                  <a:srgbClr val="1C2428"/>
-                </a:solidFill>
-                <a:latin typeface="Microsoft JhengHei"/>
-                <a:ea typeface="Microsoft JhengHei"/>
-              </a:rPr>
-              <a:t>問答、獎學金、選課、活動都從這裡進。</a:t>
-            </a:r>
-          </a:p>
-          <a:p>
-            <a:pPr algn="l">
-              <a:spcAft>
-                <a:spcPts val="700"/>
-              </a:spcAft>
-            </a:pPr>
-            <a:r>
-              <a:rPr sz="1700" b="0">
-                <a:solidFill>
-                  <a:srgbClr val="1C2428"/>
-                </a:solidFill>
-                <a:latin typeface="Microsoft JhengHei"/>
-                <a:ea typeface="Microsoft JhengHei"/>
-              </a:rPr>
-              <a:t/>
-            </a:r>
+            <a:endParaRPr sz="1700" b="0">
+              <a:solidFill>
+                <a:srgbClr val="1C2428"/>
+              </a:solidFill>
+              <a:latin typeface="Microsoft JhengHei"/>
+              <a:ea typeface="Microsoft JhengHei"/>
+            </a:endParaRPr>
           </a:p>
           <a:p>
             <a:pPr algn="l">
@@ -6044,7 +6087,7 @@
 </file>
 
 <file path=ppt/slides/slide6.xml><?xml version="1.0" encoding="utf-8"?>
-<p:sld xmlns:a="http://schemas.openxmlformats.org/drawingml/2006/main" xmlns:p="http://schemas.openxmlformats.org/presentationml/2006/main" xmlns:r="http://schemas.openxmlformats.org/officeDocument/2006/relationships">
+<p:sld xmlns:a="http://schemas.openxmlformats.org/drawingml/2006/main" xmlns:r="http://schemas.openxmlformats.org/officeDocument/2006/relationships" xmlns:p="http://schemas.openxmlformats.org/presentationml/2006/main">
   <p:cSld>
     <p:spTree>
       <p:nvGrpSpPr>
@@ -6052,7 +6095,14 @@
         <p:cNvGrpSpPr/>
         <p:nvPr/>
       </p:nvGrpSpPr>
-      <p:grpSpPr/>
+      <p:grpSpPr>
+        <a:xfrm>
+          <a:off x="0" y="0"/>
+          <a:ext cx="0" cy="0"/>
+          <a:chOff x="0" y="0"/>
+          <a:chExt cx="0" cy="0"/>
+        </a:xfrm>
+      </p:grpSpPr>
       <p:pic>
         <p:nvPicPr>
           <p:cNvPr id="2" name="Picture 1" descr="slide-bg-campus-plain.png"/>
@@ -6079,14 +6129,14 @@
       </p:pic>
       <p:sp>
         <p:nvSpPr>
-          <p:cNvPr id="3" name="TextBox 2"/>
+          <p:cNvPr id="4" name="TextBox 3"/>
           <p:cNvSpPr txBox="1"/>
           <p:nvPr/>
         </p:nvSpPr>
         <p:spPr>
           <a:xfrm>
-            <a:off x="640080" y="320040"/>
-            <a:ext cx="9144000" cy="256032"/>
+            <a:off x="640080" y="576072"/>
+            <a:ext cx="9601200" cy="411480"/>
           </a:xfrm>
           <a:prstGeom prst="rect">
             <a:avLst/>
@@ -6105,28 +6155,28 @@
               </a:spcAft>
             </a:pPr>
             <a:r>
-              <a:rPr sz="1200" b="1">
-                <a:solidFill>
-                  <a:srgbClr val="1F8A80"/>
-                </a:solidFill>
-                <a:latin typeface="Microsoft JhengHei"/>
-                <a:ea typeface="Microsoft JhengHei"/>
-              </a:rPr>
-              <a:t>Campus AI</a:t>
-            </a:r>
-          </a:p>
-        </p:txBody>
-      </p:sp>
-      <p:sp>
-        <p:nvSpPr>
-          <p:cNvPr id="4" name="TextBox 3"/>
+              <a:rPr sz="2600" b="1">
+                <a:solidFill>
+                  <a:srgbClr val="1C2428"/>
+                </a:solidFill>
+                <a:latin typeface="Microsoft JhengHei"/>
+                <a:ea typeface="Microsoft JhengHei"/>
+              </a:rPr>
+              <a:t>用了哪些技術？資料放哪？</a:t>
+            </a:r>
+          </a:p>
+        </p:txBody>
+      </p:sp>
+      <p:sp>
+        <p:nvSpPr>
+          <p:cNvPr id="5" name="TextBox 4"/>
           <p:cNvSpPr txBox="1"/>
           <p:nvPr/>
         </p:nvSpPr>
         <p:spPr>
           <a:xfrm>
-            <a:off x="640080" y="576072"/>
-            <a:ext cx="9601200" cy="411480"/>
+            <a:off x="10515600" y="411479"/>
+            <a:ext cx="1097280" cy="274320"/>
           </a:xfrm>
           <a:prstGeom prst="rect">
             <a:avLst/>
@@ -6139,34 +6189,34 @@
           </a:bodyPr>
           <a:lstStyle/>
           <a:p>
-            <a:pPr algn="l">
+            <a:pPr algn="r">
               <a:spcAft>
                 <a:spcPts val="600"/>
               </a:spcAft>
             </a:pPr>
             <a:r>
-              <a:rPr sz="2600" b="1">
-                <a:solidFill>
-                  <a:srgbClr val="1C2428"/>
-                </a:solidFill>
-                <a:latin typeface="Microsoft JhengHei"/>
-                <a:ea typeface="Microsoft JhengHei"/>
-              </a:rPr>
-              <a:t>用了哪些技術？資料放哪？</a:t>
-            </a:r>
-          </a:p>
-        </p:txBody>
-      </p:sp>
-      <p:sp>
-        <p:nvSpPr>
-          <p:cNvPr id="5" name="TextBox 4"/>
+              <a:rPr sz="1200" b="0">
+                <a:solidFill>
+                  <a:srgbClr val="5A656B"/>
+                </a:solidFill>
+                <a:latin typeface="Microsoft JhengHei"/>
+                <a:ea typeface="Microsoft JhengHei"/>
+              </a:rPr>
+              <a:t>6/9</a:t>
+            </a:r>
+          </a:p>
+        </p:txBody>
+      </p:sp>
+      <p:sp>
+        <p:nvSpPr>
+          <p:cNvPr id="6" name="TextBox 5"/>
           <p:cNvSpPr txBox="1"/>
           <p:nvPr/>
         </p:nvSpPr>
         <p:spPr>
           <a:xfrm>
-            <a:off x="10515600" y="411479"/>
-            <a:ext cx="1097280" cy="274320"/>
+            <a:off x="640080" y="1325880"/>
+            <a:ext cx="5303520" cy="5029200"/>
           </a:xfrm>
           <a:prstGeom prst="rect">
             <a:avLst/>
@@ -6179,46 +6229,6 @@
           </a:bodyPr>
           <a:lstStyle/>
           <a:p>
-            <a:pPr algn="r">
-              <a:spcAft>
-                <a:spcPts val="600"/>
-              </a:spcAft>
-            </a:pPr>
-            <a:r>
-              <a:rPr sz="1200" b="0">
-                <a:solidFill>
-                  <a:srgbClr val="5A656B"/>
-                </a:solidFill>
-                <a:latin typeface="Microsoft JhengHei"/>
-                <a:ea typeface="Microsoft JhengHei"/>
-              </a:rPr>
-              <a:t>6/9</a:t>
-            </a:r>
-          </a:p>
-        </p:txBody>
-      </p:sp>
-      <p:sp>
-        <p:nvSpPr>
-          <p:cNvPr id="6" name="TextBox 5"/>
-          <p:cNvSpPr txBox="1"/>
-          <p:nvPr/>
-        </p:nvSpPr>
-        <p:spPr>
-          <a:xfrm>
-            <a:off x="640080" y="1325880"/>
-            <a:ext cx="5303520" cy="5029200"/>
-          </a:xfrm>
-          <a:prstGeom prst="rect">
-            <a:avLst/>
-          </a:prstGeom>
-          <a:noFill/>
-        </p:spPr>
-        <p:txBody>
-          <a:bodyPr wrap="square">
-            <a:spAutoFit/>
-          </a:bodyPr>
-          <a:lstStyle/>
-          <a:p>
             <a:pPr algn="l">
               <a:spcAft>
                 <a:spcPts val="900"/>
@@ -6326,16 +6336,13 @@
                 <a:spcPts val="900"/>
               </a:spcAft>
             </a:pPr>
-            <a:r>
-              <a:rPr sz="1700" b="0">
-                <a:solidFill>
-                  <a:srgbClr val="1C2428"/>
-                </a:solidFill>
-                <a:latin typeface="Microsoft JhengHei"/>
-                <a:ea typeface="Microsoft JhengHei"/>
-              </a:rPr>
-              <a:t/>
-            </a:r>
+            <a:endParaRPr sz="1700" b="0">
+              <a:solidFill>
+                <a:srgbClr val="1C2428"/>
+              </a:solidFill>
+              <a:latin typeface="Microsoft JhengHei"/>
+              <a:ea typeface="Microsoft JhengHei"/>
+            </a:endParaRPr>
           </a:p>
           <a:p>
             <a:pPr algn="l">
@@ -6432,6 +6439,7 @@
           <a:lstStyle/>
           <a:p>
             <a:pPr algn="ctr"/>
+            <a:endParaRPr/>
           </a:p>
         </p:txBody>
       </p:sp>
@@ -6609,7 +6617,7 @@
 </file>
 
 <file path=ppt/slides/slide7.xml><?xml version="1.0" encoding="utf-8"?>
-<p:sld xmlns:a="http://schemas.openxmlformats.org/drawingml/2006/main" xmlns:p="http://schemas.openxmlformats.org/presentationml/2006/main" xmlns:r="http://schemas.openxmlformats.org/officeDocument/2006/relationships">
+<p:sld xmlns:a="http://schemas.openxmlformats.org/drawingml/2006/main" xmlns:r="http://schemas.openxmlformats.org/officeDocument/2006/relationships" xmlns:p="http://schemas.openxmlformats.org/presentationml/2006/main">
   <p:cSld>
     <p:spTree>
       <p:nvGrpSpPr>
@@ -6617,7 +6625,14 @@
         <p:cNvGrpSpPr/>
         <p:nvPr/>
       </p:nvGrpSpPr>
-      <p:grpSpPr/>
+      <p:grpSpPr>
+        <a:xfrm>
+          <a:off x="0" y="0"/>
+          <a:ext cx="0" cy="0"/>
+          <a:chOff x="0" y="0"/>
+          <a:chExt cx="0" cy="0"/>
+        </a:xfrm>
+      </p:grpSpPr>
       <p:pic>
         <p:nvPicPr>
           <p:cNvPr id="2" name="Picture 1" descr="slide-bg-campus-plain.png"/>
@@ -6642,46 +6657,6 @@
           </a:prstGeom>
         </p:spPr>
       </p:pic>
-      <p:sp>
-        <p:nvSpPr>
-          <p:cNvPr id="3" name="TextBox 2"/>
-          <p:cNvSpPr txBox="1"/>
-          <p:nvPr/>
-        </p:nvSpPr>
-        <p:spPr>
-          <a:xfrm>
-            <a:off x="640080" y="320040"/>
-            <a:ext cx="9144000" cy="256032"/>
-          </a:xfrm>
-          <a:prstGeom prst="rect">
-            <a:avLst/>
-          </a:prstGeom>
-          <a:noFill/>
-        </p:spPr>
-        <p:txBody>
-          <a:bodyPr wrap="square">
-            <a:spAutoFit/>
-          </a:bodyPr>
-          <a:lstStyle/>
-          <a:p>
-            <a:pPr algn="l">
-              <a:spcAft>
-                <a:spcPts val="600"/>
-              </a:spcAft>
-            </a:pPr>
-            <a:r>
-              <a:rPr sz="1200" b="1">
-                <a:solidFill>
-                  <a:srgbClr val="1F8A80"/>
-                </a:solidFill>
-                <a:latin typeface="Microsoft JhengHei"/>
-                <a:ea typeface="Microsoft JhengHei"/>
-              </a:rPr>
-              <a:t>Campus AI</a:t>
-            </a:r>
-          </a:p>
-        </p:txBody>
-      </p:sp>
       <p:sp>
         <p:nvSpPr>
           <p:cNvPr id="4" name="TextBox 3"/>
@@ -6804,6 +6779,7 @@
           <a:lstStyle/>
           <a:p>
             <a:pPr algn="ctr"/>
+            <a:endParaRPr/>
           </a:p>
         </p:txBody>
       </p:sp>
@@ -6929,6 +6905,7 @@
           <a:lstStyle/>
           <a:p>
             <a:pPr algn="ctr"/>
+            <a:endParaRPr/>
           </a:p>
         </p:txBody>
       </p:sp>
@@ -7054,6 +7031,7 @@
           <a:lstStyle/>
           <a:p>
             <a:pPr algn="ctr"/>
+            <a:endParaRPr/>
           </a:p>
         </p:txBody>
       </p:sp>
@@ -7179,6 +7157,7 @@
           <a:lstStyle/>
           <a:p>
             <a:pPr algn="ctr"/>
+            <a:endParaRPr/>
           </a:p>
         </p:txBody>
       </p:sp>
@@ -7304,6 +7283,7 @@
           <a:lstStyle/>
           <a:p>
             <a:pPr algn="ctr"/>
+            <a:endParaRPr/>
           </a:p>
         </p:txBody>
       </p:sp>
@@ -7448,16 +7428,13 @@
                 <a:spcPts val="1000"/>
               </a:spcAft>
             </a:pPr>
-            <a:r>
-              <a:rPr sz="1700" b="0">
-                <a:solidFill>
-                  <a:srgbClr val="1C2428"/>
-                </a:solidFill>
-                <a:latin typeface="Microsoft JhengHei"/>
-                <a:ea typeface="Microsoft JhengHei"/>
-              </a:rPr>
-              <a:t/>
-            </a:r>
+            <a:endParaRPr sz="1700" b="0">
+              <a:solidFill>
+                <a:srgbClr val="1C2428"/>
+              </a:solidFill>
+              <a:latin typeface="Microsoft JhengHei"/>
+              <a:ea typeface="Microsoft JhengHei"/>
+            </a:endParaRPr>
           </a:p>
           <a:p>
             <a:pPr algn="l">
@@ -7487,7 +7464,7 @@
 </file>
 
 <file path=ppt/slides/slide8.xml><?xml version="1.0" encoding="utf-8"?>
-<p:sld xmlns:a="http://schemas.openxmlformats.org/drawingml/2006/main" xmlns:p="http://schemas.openxmlformats.org/presentationml/2006/main" xmlns:r="http://schemas.openxmlformats.org/officeDocument/2006/relationships">
+<p:sld xmlns:a="http://schemas.openxmlformats.org/drawingml/2006/main" xmlns:r="http://schemas.openxmlformats.org/officeDocument/2006/relationships" xmlns:p="http://schemas.openxmlformats.org/presentationml/2006/main">
   <p:cSld>
     <p:spTree>
       <p:nvGrpSpPr>
@@ -7495,7 +7472,14 @@
         <p:cNvGrpSpPr/>
         <p:nvPr/>
       </p:nvGrpSpPr>
-      <p:grpSpPr/>
+      <p:grpSpPr>
+        <a:xfrm>
+          <a:off x="0" y="0"/>
+          <a:ext cx="0" cy="0"/>
+          <a:chOff x="0" y="0"/>
+          <a:chExt cx="0" cy="0"/>
+        </a:xfrm>
+      </p:grpSpPr>
       <p:pic>
         <p:nvPicPr>
           <p:cNvPr id="2" name="Picture 1" descr="slide-bg-campus-plain.png"/>
@@ -7520,46 +7504,6 @@
           </a:prstGeom>
         </p:spPr>
       </p:pic>
-      <p:sp>
-        <p:nvSpPr>
-          <p:cNvPr id="3" name="TextBox 2"/>
-          <p:cNvSpPr txBox="1"/>
-          <p:nvPr/>
-        </p:nvSpPr>
-        <p:spPr>
-          <a:xfrm>
-            <a:off x="640080" y="320040"/>
-            <a:ext cx="9144000" cy="274320"/>
-          </a:xfrm>
-          <a:prstGeom prst="rect">
-            <a:avLst/>
-          </a:prstGeom>
-          <a:noFill/>
-        </p:spPr>
-        <p:txBody>
-          <a:bodyPr wrap="square">
-            <a:spAutoFit/>
-          </a:bodyPr>
-          <a:lstStyle/>
-          <a:p>
-            <a:pPr algn="l">
-              <a:spcAft>
-                <a:spcPts val="600"/>
-              </a:spcAft>
-            </a:pPr>
-            <a:r>
-              <a:rPr sz="1200" b="1">
-                <a:solidFill>
-                  <a:srgbClr val="1F8A80"/>
-                </a:solidFill>
-                <a:latin typeface="Microsoft JhengHei"/>
-                <a:ea typeface="Microsoft JhengHei"/>
-              </a:rPr>
-              <a:t>Campus AI</a:t>
-            </a:r>
-          </a:p>
-        </p:txBody>
-      </p:sp>
       <p:sp>
         <p:nvSpPr>
           <p:cNvPr id="4" name="TextBox 3"/>
@@ -7680,6 +7624,7 @@
           <a:lstStyle/>
           <a:p>
             <a:pPr algn="ctr"/>
+            <a:endParaRPr/>
           </a:p>
         </p:txBody>
       </p:sp>
@@ -7711,14 +7656,44 @@
               </a:spcAft>
             </a:pPr>
             <a:r>
-              <a:rPr sz="1700" b="0">
-                <a:solidFill>
-                  <a:srgbClr val="1C2428"/>
-                </a:solidFill>
-                <a:latin typeface="Microsoft JhengHei"/>
-                <a:ea typeface="Microsoft JhengHei"/>
-              </a:rPr>
-              <a:t>先打開 SSMS，給大家看 Students 的 GPA。</a:t>
+              <a:rPr sz="1700" b="0" dirty="0" err="1">
+                <a:solidFill>
+                  <a:srgbClr val="1C2428"/>
+                </a:solidFill>
+                <a:latin typeface="Microsoft JhengHei"/>
+                <a:ea typeface="Microsoft JhengHei"/>
+              </a:rPr>
+              <a:t>先打開</a:t>
+            </a:r>
+            <a:r>
+              <a:rPr sz="1700" b="0" dirty="0">
+                <a:solidFill>
+                  <a:srgbClr val="1C2428"/>
+                </a:solidFill>
+                <a:latin typeface="Microsoft JhengHei"/>
+                <a:ea typeface="Microsoft JhengHei"/>
+              </a:rPr>
+              <a:t> </a:t>
+            </a:r>
+            <a:r>
+              <a:rPr sz="1700" b="0" dirty="0" err="1">
+                <a:solidFill>
+                  <a:srgbClr val="1C2428"/>
+                </a:solidFill>
+                <a:latin typeface="Microsoft JhengHei"/>
+                <a:ea typeface="Microsoft JhengHei"/>
+              </a:rPr>
+              <a:t>SSMS，給大家看</a:t>
+            </a:r>
+            <a:r>
+              <a:rPr sz="1700" b="0" dirty="0">
+                <a:solidFill>
+                  <a:srgbClr val="1C2428"/>
+                </a:solidFill>
+                <a:latin typeface="Microsoft JhengHei"/>
+                <a:ea typeface="Microsoft JhengHei"/>
+              </a:rPr>
+              <a:t> Students 的 GPA。</a:t>
             </a:r>
           </a:p>
           <a:p>
@@ -7727,16 +7702,13 @@
                 <a:spcPts val="900"/>
               </a:spcAft>
             </a:pPr>
-            <a:r>
-              <a:rPr sz="1700" b="0">
-                <a:solidFill>
-                  <a:srgbClr val="1C2428"/>
-                </a:solidFill>
-                <a:latin typeface="Microsoft JhengHei"/>
-                <a:ea typeface="Microsoft JhengHei"/>
-              </a:rPr>
-              <a:t/>
-            </a:r>
+            <a:endParaRPr sz="1700" b="0" dirty="0">
+              <a:solidFill>
+                <a:srgbClr val="1C2428"/>
+              </a:solidFill>
+              <a:latin typeface="Microsoft JhengHei"/>
+              <a:ea typeface="Microsoft JhengHei"/>
+            </a:endParaRPr>
           </a:p>
           <a:p>
             <a:pPr algn="l">
@@ -7745,14 +7717,24 @@
               </a:spcAft>
             </a:pPr>
             <a:r>
-              <a:rPr sz="1700" b="0">
-                <a:solidFill>
-                  <a:srgbClr val="1C2428"/>
-                </a:solidFill>
-                <a:latin typeface="Microsoft JhengHei"/>
-                <a:ea typeface="Microsoft JhengHei"/>
-              </a:rPr>
-              <a:t>再登入網站，走一圈主畫面的三塊入口。</a:t>
+              <a:rPr sz="1700" b="0" dirty="0" err="1">
+                <a:solidFill>
+                  <a:srgbClr val="1C2428"/>
+                </a:solidFill>
+                <a:latin typeface="Microsoft JhengHei"/>
+                <a:ea typeface="Microsoft JhengHei"/>
+              </a:rPr>
+              <a:t>再登入網站，走一圈主畫面的三塊入口</a:t>
+            </a:r>
+            <a:r>
+              <a:rPr sz="1700" b="0" dirty="0">
+                <a:solidFill>
+                  <a:srgbClr val="1C2428"/>
+                </a:solidFill>
+                <a:latin typeface="Microsoft JhengHei"/>
+                <a:ea typeface="Microsoft JhengHei"/>
+              </a:rPr>
+              <a:t>。</a:t>
             </a:r>
           </a:p>
           <a:p>
@@ -7761,16 +7743,13 @@
                 <a:spcPts val="900"/>
               </a:spcAft>
             </a:pPr>
-            <a:r>
-              <a:rPr sz="1700" b="0">
-                <a:solidFill>
-                  <a:srgbClr val="1C2428"/>
-                </a:solidFill>
-                <a:latin typeface="Microsoft JhengHei"/>
-                <a:ea typeface="Microsoft JhengHei"/>
-              </a:rPr>
-              <a:t/>
-            </a:r>
+            <a:endParaRPr sz="1700" b="0" dirty="0">
+              <a:solidFill>
+                <a:srgbClr val="1C2428"/>
+              </a:solidFill>
+              <a:latin typeface="Microsoft JhengHei"/>
+              <a:ea typeface="Microsoft JhengHei"/>
+            </a:endParaRPr>
           </a:p>
           <a:p>
             <a:pPr algn="l">
@@ -7779,14 +7758,34 @@
               </a:spcAft>
             </a:pPr>
             <a:r>
-              <a:rPr sz="1700" b="0">
-                <a:solidFill>
-                  <a:srgbClr val="1C2428"/>
-                </a:solidFill>
-                <a:latin typeface="Microsoft JhengHei"/>
-                <a:ea typeface="Microsoft JhengHei"/>
-              </a:rPr>
-              <a:t>進 AI，問獎學金，對一下是不是跟資料庫條件對得上。</a:t>
+              <a:rPr sz="1700" b="0" dirty="0">
+                <a:solidFill>
+                  <a:srgbClr val="1C2428"/>
+                </a:solidFill>
+                <a:latin typeface="Microsoft JhengHei"/>
+                <a:ea typeface="Microsoft JhengHei"/>
+              </a:rPr>
+              <a:t>進 </a:t>
+            </a:r>
+            <a:r>
+              <a:rPr sz="1700" b="0" dirty="0" err="1">
+                <a:solidFill>
+                  <a:srgbClr val="1C2428"/>
+                </a:solidFill>
+                <a:latin typeface="Microsoft JhengHei"/>
+                <a:ea typeface="Microsoft JhengHei"/>
+              </a:rPr>
+              <a:t>AI，問獎學金，對一下是不是跟資料庫條件對得上</a:t>
+            </a:r>
+            <a:r>
+              <a:rPr sz="1700" b="0" dirty="0">
+                <a:solidFill>
+                  <a:srgbClr val="1C2428"/>
+                </a:solidFill>
+                <a:latin typeface="Microsoft JhengHei"/>
+                <a:ea typeface="Microsoft JhengHei"/>
+              </a:rPr>
+              <a:t>。</a:t>
             </a:r>
           </a:p>
           <a:p>
@@ -7795,16 +7794,13 @@
                 <a:spcPts val="900"/>
               </a:spcAft>
             </a:pPr>
-            <a:r>
-              <a:rPr sz="1700" b="0">
-                <a:solidFill>
-                  <a:srgbClr val="1C2428"/>
-                </a:solidFill>
-                <a:latin typeface="Microsoft JhengHei"/>
-                <a:ea typeface="Microsoft JhengHei"/>
-              </a:rPr>
-              <a:t/>
-            </a:r>
+            <a:endParaRPr sz="1700" b="0" dirty="0">
+              <a:solidFill>
+                <a:srgbClr val="1C2428"/>
+              </a:solidFill>
+              <a:latin typeface="Microsoft JhengHei"/>
+              <a:ea typeface="Microsoft JhengHei"/>
+            </a:endParaRPr>
           </a:p>
           <a:p>
             <a:pPr algn="l">
@@ -7813,14 +7809,24 @@
               </a:spcAft>
             </a:pPr>
             <a:r>
-              <a:rPr sz="1700" b="0">
-                <a:solidFill>
-                  <a:srgbClr val="1C2428"/>
-                </a:solidFill>
-                <a:latin typeface="Microsoft JhengHei"/>
-                <a:ea typeface="Microsoft JhengHei"/>
-              </a:rPr>
-              <a:t>若問校規，打開執行紀錄，指出有打到 MCP。</a:t>
+              <a:rPr sz="1700" b="0" dirty="0" err="1">
+                <a:solidFill>
+                  <a:srgbClr val="1C2428"/>
+                </a:solidFill>
+                <a:latin typeface="Microsoft JhengHei"/>
+                <a:ea typeface="Microsoft JhengHei"/>
+              </a:rPr>
+              <a:t>若問校規，打開執行紀錄，指出有打到</a:t>
+            </a:r>
+            <a:r>
+              <a:rPr sz="1700" b="0" dirty="0">
+                <a:solidFill>
+                  <a:srgbClr val="1C2428"/>
+                </a:solidFill>
+                <a:latin typeface="Microsoft JhengHei"/>
+                <a:ea typeface="Microsoft JhengHei"/>
+              </a:rPr>
+              <a:t> MCP。</a:t>
             </a:r>
           </a:p>
           <a:p>
@@ -7829,16 +7835,13 @@
                 <a:spcPts val="900"/>
               </a:spcAft>
             </a:pPr>
-            <a:r>
-              <a:rPr sz="1700" b="0">
-                <a:solidFill>
-                  <a:srgbClr val="1C2428"/>
-                </a:solidFill>
-                <a:latin typeface="Microsoft JhengHei"/>
-                <a:ea typeface="Microsoft JhengHei"/>
-              </a:rPr>
-              <a:t/>
-            </a:r>
+            <a:endParaRPr sz="1700" b="0" dirty="0">
+              <a:solidFill>
+                <a:srgbClr val="1C2428"/>
+              </a:solidFill>
+              <a:latin typeface="Microsoft JhengHei"/>
+              <a:ea typeface="Microsoft JhengHei"/>
+            </a:endParaRPr>
           </a:p>
           <a:p>
             <a:pPr algn="l">
@@ -7847,14 +7850,64 @@
               </a:spcAft>
             </a:pPr>
             <a:r>
-              <a:rPr sz="1700" b="0">
-                <a:solidFill>
-                  <a:srgbClr val="1C2428"/>
-                </a:solidFill>
-                <a:latin typeface="Microsoft JhengHei"/>
-                <a:ea typeface="Microsoft JhengHei"/>
-              </a:rPr>
-              <a:t>收尾：入口照身分與功能分；資料在 SQL；問答找文件；回覆由 Gemini 整理。</a:t>
+              <a:rPr sz="1700" b="0" dirty="0" err="1">
+                <a:solidFill>
+                  <a:srgbClr val="1C2428"/>
+                </a:solidFill>
+                <a:latin typeface="Microsoft JhengHei"/>
+                <a:ea typeface="Microsoft JhengHei"/>
+              </a:rPr>
+              <a:t>收尾：入口照身分與功能分；資料在</a:t>
+            </a:r>
+            <a:r>
+              <a:rPr sz="1700" b="0" dirty="0">
+                <a:solidFill>
+                  <a:srgbClr val="1C2428"/>
+                </a:solidFill>
+                <a:latin typeface="Microsoft JhengHei"/>
+                <a:ea typeface="Microsoft JhengHei"/>
+              </a:rPr>
+              <a:t> </a:t>
+            </a:r>
+            <a:r>
+              <a:rPr sz="1700" b="0" dirty="0" err="1">
+                <a:solidFill>
+                  <a:srgbClr val="1C2428"/>
+                </a:solidFill>
+                <a:latin typeface="Microsoft JhengHei"/>
+                <a:ea typeface="Microsoft JhengHei"/>
+              </a:rPr>
+              <a:t>SQL；問答找文件；回覆由</a:t>
+            </a:r>
+            <a:r>
+              <a:rPr sz="1700" b="0" dirty="0">
+                <a:solidFill>
+                  <a:srgbClr val="1C2428"/>
+                </a:solidFill>
+                <a:latin typeface="Microsoft JhengHei"/>
+                <a:ea typeface="Microsoft JhengHei"/>
+              </a:rPr>
+              <a:t> Gemini </a:t>
+            </a:r>
+            <a:r>
+              <a:rPr sz="1700" b="0" dirty="0" err="1">
+                <a:solidFill>
+                  <a:srgbClr val="1C2428"/>
+                </a:solidFill>
+                <a:latin typeface="Microsoft JhengHei"/>
+                <a:ea typeface="Microsoft JhengHei"/>
+              </a:rPr>
+              <a:t>整理</a:t>
+            </a:r>
+            <a:r>
+              <a:rPr sz="1700" b="0" dirty="0">
+                <a:solidFill>
+                  <a:srgbClr val="1C2428"/>
+                </a:solidFill>
+                <a:latin typeface="Microsoft JhengHei"/>
+                <a:ea typeface="Microsoft JhengHei"/>
+              </a:rPr>
+              <a:t>。</a:t>
             </a:r>
           </a:p>
         </p:txBody>
@@ -7868,7 +7921,7 @@
 </file>
 
 <file path=ppt/slides/slide9.xml><?xml version="1.0" encoding="utf-8"?>
-<p:sld xmlns:a="http://schemas.openxmlformats.org/drawingml/2006/main" xmlns:p="http://schemas.openxmlformats.org/presentationml/2006/main" xmlns:r="http://schemas.openxmlformats.org/officeDocument/2006/relationships">
+<p:sld xmlns:a="http://schemas.openxmlformats.org/drawingml/2006/main" xmlns:r="http://schemas.openxmlformats.org/officeDocument/2006/relationships" xmlns:p="http://schemas.openxmlformats.org/presentationml/2006/main">
   <p:cSld>
     <p:spTree>
       <p:nvGrpSpPr>
@@ -7876,7 +7929,14 @@
         <p:cNvGrpSpPr/>
         <p:nvPr/>
       </p:nvGrpSpPr>
-      <p:grpSpPr/>
+      <p:grpSpPr>
+        <a:xfrm>
+          <a:off x="0" y="0"/>
+          <a:ext cx="0" cy="0"/>
+          <a:chOff x="0" y="0"/>
+          <a:chExt cx="0" cy="0"/>
+        </a:xfrm>
+      </p:grpSpPr>
       <p:pic>
         <p:nvPicPr>
           <p:cNvPr id="2" name="Picture 1" descr="slide-bg-campus-plain.png"/>
@@ -7943,6 +8003,7 @@
           <a:lstStyle/>
           <a:p>
             <a:pPr algn="ctr"/>
+            <a:endParaRPr/>
           </a:p>
         </p:txBody>
       </p:sp>

</xml_diff>